<commit_message>
fix: verify ROP IM and PPOIS reports and native diagrams
</commit_message>
<xml_diff>
--- a/4/РОП/Практики_1-8/Презентации/РОП_Практическая_1_АлбахтинИВ.pptx
+++ b/4/РОП/Практики_1-8/Презентации/РОП_Практическая_1_АлбахтинИВ.pptx
@@ -2,27 +2,27 @@
 <file path=ppt/presentation.xml><?xml version="1.0" encoding="utf-8"?>
 <p:presentation xmlns:p="http://schemas.openxmlformats.org/presentationml/2006/main">
   <p:sldMasterIdLst>
-    <p:sldMasterId xmlns:r="http://schemas.openxmlformats.org/officeDocument/2006/relationships" id="2147483648" r:id="R9ca80cad1a5d4ca9"/>
+    <p:sldMasterId xmlns:r="http://schemas.openxmlformats.org/officeDocument/2006/relationships" id="2147483648" r:id="Rda2fe53818d24a5e"/>
   </p:sldMasterIdLst>
   <p:notesMasterIdLst>
-    <p:notesMasterId xmlns:r="http://schemas.openxmlformats.org/officeDocument/2006/relationships" r:id="R49f404efb9934b5a"/>
+    <p:notesMasterId xmlns:r="http://schemas.openxmlformats.org/officeDocument/2006/relationships" r:id="Rebcee4eba1424b46"/>
   </p:notesMasterIdLst>
   <p:sldIdLst>
-    <p:sldId xmlns:r="http://schemas.openxmlformats.org/officeDocument/2006/relationships" id="256" r:id="R37e241a9171b41fc"/>
-    <p:sldId xmlns:r="http://schemas.openxmlformats.org/officeDocument/2006/relationships" id="257" r:id="R636a80e23b9c4b15"/>
-    <p:sldId xmlns:r="http://schemas.openxmlformats.org/officeDocument/2006/relationships" id="258" r:id="R891fc1f3907348ff"/>
-    <p:sldId xmlns:r="http://schemas.openxmlformats.org/officeDocument/2006/relationships" id="259" r:id="R01cb0c52733f45a0"/>
-    <p:sldId xmlns:r="http://schemas.openxmlformats.org/officeDocument/2006/relationships" id="260" r:id="Rca9a4091d2d041dc"/>
-    <p:sldId xmlns:r="http://schemas.openxmlformats.org/officeDocument/2006/relationships" id="261" r:id="R38590016724a44a6"/>
-    <p:sldId xmlns:r="http://schemas.openxmlformats.org/officeDocument/2006/relationships" id="262" r:id="Rfd92d6a29a7149bb"/>
-    <p:sldId xmlns:r="http://schemas.openxmlformats.org/officeDocument/2006/relationships" id="263" r:id="R756201dcf1d14bb1"/>
-    <p:sldId xmlns:r="http://schemas.openxmlformats.org/officeDocument/2006/relationships" id="264" r:id="R653cfaf18db348aa"/>
-    <p:sldId xmlns:r="http://schemas.openxmlformats.org/officeDocument/2006/relationships" id="265" r:id="R122e89fb744642b9"/>
-    <p:sldId xmlns:r="http://schemas.openxmlformats.org/officeDocument/2006/relationships" id="266" r:id="Rc6f10dc185304c3d"/>
-    <p:sldId xmlns:r="http://schemas.openxmlformats.org/officeDocument/2006/relationships" id="267" r:id="R067ecf3288574e79"/>
-    <p:sldId xmlns:r="http://schemas.openxmlformats.org/officeDocument/2006/relationships" id="268" r:id="R2270f6ab14924eee"/>
-    <p:sldId xmlns:r="http://schemas.openxmlformats.org/officeDocument/2006/relationships" id="269" r:id="R7c2c396159684bd8"/>
-    <p:sldId xmlns:r="http://schemas.openxmlformats.org/officeDocument/2006/relationships" id="270" r:id="R19b7d5a9577f4428"/>
+    <p:sldId xmlns:r="http://schemas.openxmlformats.org/officeDocument/2006/relationships" id="256" r:id="R966ac7618b4041e9"/>
+    <p:sldId xmlns:r="http://schemas.openxmlformats.org/officeDocument/2006/relationships" id="257" r:id="R57be7c10f8254972"/>
+    <p:sldId xmlns:r="http://schemas.openxmlformats.org/officeDocument/2006/relationships" id="258" r:id="Re6d7fa95d63b4213"/>
+    <p:sldId xmlns:r="http://schemas.openxmlformats.org/officeDocument/2006/relationships" id="259" r:id="R6fc985d289194575"/>
+    <p:sldId xmlns:r="http://schemas.openxmlformats.org/officeDocument/2006/relationships" id="260" r:id="R5ac8c20e965a4545"/>
+    <p:sldId xmlns:r="http://schemas.openxmlformats.org/officeDocument/2006/relationships" id="261" r:id="R285dff1a64d946a1"/>
+    <p:sldId xmlns:r="http://schemas.openxmlformats.org/officeDocument/2006/relationships" id="262" r:id="R82cdc933add64078"/>
+    <p:sldId xmlns:r="http://schemas.openxmlformats.org/officeDocument/2006/relationships" id="263" r:id="R03d19c3c78a74db2"/>
+    <p:sldId xmlns:r="http://schemas.openxmlformats.org/officeDocument/2006/relationships" id="264" r:id="R977ca84786834c78"/>
+    <p:sldId xmlns:r="http://schemas.openxmlformats.org/officeDocument/2006/relationships" id="265" r:id="R3a1af721bf08482d"/>
+    <p:sldId xmlns:r="http://schemas.openxmlformats.org/officeDocument/2006/relationships" id="266" r:id="Rd0673fe8d6ba4efb"/>
+    <p:sldId xmlns:r="http://schemas.openxmlformats.org/officeDocument/2006/relationships" id="267" r:id="R06c786a9fd1341ce"/>
+    <p:sldId xmlns:r="http://schemas.openxmlformats.org/officeDocument/2006/relationships" id="268" r:id="Ra9d64bd86f3945a9"/>
+    <p:sldId xmlns:r="http://schemas.openxmlformats.org/officeDocument/2006/relationships" id="269" r:id="R779fb2144a164acd"/>
+    <p:sldId xmlns:r="http://schemas.openxmlformats.org/officeDocument/2006/relationships" id="270" r:id="Rd38ffc921ca34c3d"/>
   </p:sldIdLst>
   <p:sldSz cx="12192000" cy="6858000"/>
   <p:notesSz cx="6858000" cy="9144000"/>
@@ -761,7 +761,7 @@
           </a:p>
           <a:p xmlns:a="http://schemas.openxmlformats.org/drawingml/2006/main">
             <a:r>
-              <a:t>Оценки 0–5 получены в рамках учебного сравнения.</a:t>
+              <a:t>Оценки 0–5: девять критериев предыдущего слайда, равные веса. Средние округлены до 0,1 балла. 5,0 для целевой ИС — проектная оценка, не результат испытаний.</a:t>
             </a:r>
           </a:p>
         </p:txBody>
@@ -1579,7 +1579,7 @@
   </p:cSld>
   <p:clrMap bg1="lt1" tx1="dk1" bg2="lt2" tx2="dk2" accent1="accent1" accent2="accent2" accent3="accent3" accent4="accent4" accent5="accent5" accent6="accent6" hlink="hlink" folHlink="folHlink"/>
   <p:sldLayoutIdLst>
-    <p:sldLayoutId xmlns:r="http://schemas.openxmlformats.org/officeDocument/2006/relationships" id="2147483649" r:id="R665bbcb66e9b4114"/>
+    <p:sldLayoutId xmlns:r="http://schemas.openxmlformats.org/officeDocument/2006/relationships" id="2147483649" r:id="R50dc7aff4979428e"/>
   </p:sldLayoutIdLst>
   <p:txStyles>
     <p:titleStyle>
@@ -2106,6 +2106,246 @@
 </a:theme>
 </file>
 
+<file path=ppt/slides/charts/chart1.xml><?xml version="1.0" encoding="utf-8"?>
+<c:chartSpace xmlns:c="http://schemas.openxmlformats.org/drawingml/2006/chart" xmlns:r="http://schemas.openxmlformats.org/officeDocument/2006/relationships">
+  <c:lang val="en-US"/>
+  <c:chart>
+    <c:title>
+      <c:tx>
+        <c:rich>
+          <a:bodyPr xmlns:a="http://schemas.openxmlformats.org/drawingml/2006/main"/>
+          <a:lstStyle xmlns:a="http://schemas.openxmlformats.org/drawingml/2006/main"/>
+          <a:p xmlns:a="http://schemas.openxmlformats.org/drawingml/2006/main">
+            <a:r>
+              <a:rPr sz="1800">
+                <a:solidFill>
+                  <a:srgbClr val="161616"/>
+                </a:solidFill>
+                <a:latin typeface="Arial"/>
+                <a:ea typeface="Arial"/>
+                <a:cs typeface="Arial"/>
+              </a:rPr>
+              <a:t>Средняя оценка, баллы (0–5)</a:t>
+            </a:r>
+          </a:p>
+        </c:rich>
+      </c:tx>
+      <c:overlay val="0"/>
+      <c:txPr>
+        <a:bodyPr xmlns:a="http://schemas.openxmlformats.org/drawingml/2006/main" anchorCtr="1"/>
+        <a:lstStyle xmlns:a="http://schemas.openxmlformats.org/drawingml/2006/main"/>
+        <a:p xmlns:a="http://schemas.openxmlformats.org/drawingml/2006/main">
+          <a:pPr>
+            <a:defRPr sz="1800">
+              <a:solidFill>
+                <a:srgbClr val="161616"/>
+              </a:solidFill>
+              <a:latin typeface="Arial"/>
+              <a:ea typeface="Arial"/>
+              <a:cs typeface="Arial"/>
+            </a:defRPr>
+          </a:pPr>
+        </a:p>
+      </c:txPr>
+    </c:title>
+    <c:plotArea>
+      <c:barChart>
+        <c:barDir val="col"/>
+        <c:grouping val="clustered"/>
+        <c:varyColors val="0"/>
+        <c:ser>
+          <c:idx val="0"/>
+          <c:order val="0"/>
+          <c:tx>
+            <c:v>Средняя оценка</c:v>
+          </c:tx>
+          <c:spPr>
+            <a:solidFill xmlns:a="http://schemas.openxmlformats.org/drawingml/2006/main">
+              <a:srgbClr val="444444"/>
+            </a:solidFill>
+          </c:spPr>
+          <c:cat>
+            <c:strRef>
+              <c:f>'Chart Data'!$A$2:$A$6</c:f>
+              <c:strCache>
+                <c:ptCount val="5"/>
+                <c:pt idx="0">
+                  <c:v>Ozon Seller</c:v>
+                </c:pt>
+                <c:pt idx="1">
+                  <c:v>1С:ERP</c:v>
+                </c:pt>
+                <c:pt idx="2">
+                  <c:v>Pimcore</c:v>
+                </c:pt>
+                <c:pt idx="3">
+                  <c:v>Akeneo</c:v>
+                </c:pt>
+                <c:pt idx="4">
+                  <c:v>Целевая ИС</c:v>
+                </c:pt>
+              </c:strCache>
+            </c:strRef>
+          </c:cat>
+          <c:val>
+            <c:numRef>
+              <c:f>'Chart Data'!$B$2:$B$6</c:f>
+              <c:numCache>
+                <c:formatCode>0.0</c:formatCode>
+                <c:ptCount val="5"/>
+                <c:pt idx="0">
+                  <c:v>2.1</c:v>
+                </c:pt>
+                <c:pt idx="1">
+                  <c:v>3.7</c:v>
+                </c:pt>
+                <c:pt idx="2">
+                  <c:v>3.7</c:v>
+                </c:pt>
+                <c:pt idx="3">
+                  <c:v>3.1</c:v>
+                </c:pt>
+                <c:pt idx="4">
+                  <c:v>5</c:v>
+                </c:pt>
+              </c:numCache>
+            </c:numRef>
+          </c:val>
+        </c:ser>
+        <c:dLbls>
+          <c:txPr>
+            <a:bodyPr xmlns:a="http://schemas.openxmlformats.org/drawingml/2006/main" anchorCtr="1"/>
+            <a:lstStyle xmlns:a="http://schemas.openxmlformats.org/drawingml/2006/main"/>
+            <a:p xmlns:a="http://schemas.openxmlformats.org/drawingml/2006/main">
+              <a:pPr>
+                <a:defRPr sz="1800">
+                  <a:solidFill>
+                    <a:srgbClr val="161616"/>
+                  </a:solidFill>
+                  <a:latin typeface="Arial"/>
+                  <a:ea typeface="Arial"/>
+                  <a:cs typeface="Arial"/>
+                </a:defRPr>
+              </a:pPr>
+            </a:p>
+          </c:txPr>
+          <c:dLblPos val="outEnd"/>
+          <c:showLegendKey val="0"/>
+          <c:showVal val="1"/>
+          <c:showCatName val="0"/>
+          <c:showSerName val="0"/>
+          <c:showPercent val="0"/>
+          <c:showBubbleSize val="0"/>
+          <c:showLeaderLines val="0"/>
+        </c:dLbls>
+        <c:gapWidth val="90"/>
+        <c:axId val="48650112"/>
+        <c:axId val="48672768"/>
+      </c:barChart>
+      <c:catAx>
+        <c:axId val="48650112"/>
+        <c:scaling>
+          <c:orientation val="minMax"/>
+        </c:scaling>
+        <c:delete val="0"/>
+        <c:axPos val="b"/>
+        <c:numFmt formatCode="General"/>
+        <c:majorTickMark val="none"/>
+        <c:minorTickMark val="none"/>
+        <c:spPr>
+          <a:ln xmlns:a="http://schemas.openxmlformats.org/drawingml/2006/main" w="9525">
+            <a:solidFill>
+              <a:srgbClr val="D4D4D4"/>
+            </a:solidFill>
+            <a:prstDash val="solid"/>
+          </a:ln>
+        </c:spPr>
+        <c:txPr>
+          <a:bodyPr xmlns:a="http://schemas.openxmlformats.org/drawingml/2006/main" anchorCtr="1"/>
+          <a:lstStyle xmlns:a="http://schemas.openxmlformats.org/drawingml/2006/main"/>
+          <a:p xmlns:a="http://schemas.openxmlformats.org/drawingml/2006/main">
+            <a:pPr>
+              <a:defRPr sz="1800">
+                <a:solidFill>
+                  <a:srgbClr val="161616"/>
+                </a:solidFill>
+                <a:latin typeface="Arial"/>
+                <a:ea typeface="Arial"/>
+                <a:cs typeface="Arial"/>
+              </a:defRPr>
+            </a:pPr>
+          </a:p>
+        </c:txPr>
+        <c:crossAx val="48672768"/>
+      </c:catAx>
+      <c:valAx>
+        <c:axId val="48672768"/>
+        <c:scaling>
+          <c:orientation val="minMax"/>
+          <c:max val="5"/>
+          <c:min val="0"/>
+        </c:scaling>
+        <c:delete val="0"/>
+        <c:axPos val="l"/>
+        <c:majorGridlines>
+          <c:spPr>
+            <a:ln xmlns:a="http://schemas.openxmlformats.org/drawingml/2006/main" w="9525">
+              <a:solidFill>
+                <a:srgbClr val="DDDDDD"/>
+              </a:solidFill>
+            </a:ln>
+          </c:spPr>
+        </c:majorGridlines>
+        <c:numFmt formatCode="0"/>
+        <c:majorTickMark val="none"/>
+        <c:minorTickMark val="none"/>
+        <c:spPr>
+          <a:ln xmlns:a="http://schemas.openxmlformats.org/drawingml/2006/main" w="9525">
+            <a:solidFill>
+              <a:srgbClr val="D4D4D4"/>
+            </a:solidFill>
+            <a:prstDash val="solid"/>
+          </a:ln>
+        </c:spPr>
+        <c:txPr>
+          <a:bodyPr xmlns:a="http://schemas.openxmlformats.org/drawingml/2006/main" anchorCtr="1"/>
+          <a:lstStyle xmlns:a="http://schemas.openxmlformats.org/drawingml/2006/main"/>
+          <a:p xmlns:a="http://schemas.openxmlformats.org/drawingml/2006/main">
+            <a:pPr>
+              <a:defRPr sz="1650">
+                <a:solidFill>
+                  <a:srgbClr val="161616"/>
+                </a:solidFill>
+                <a:latin typeface="Arial"/>
+                <a:ea typeface="Arial"/>
+                <a:cs typeface="Arial"/>
+              </a:defRPr>
+            </a:pPr>
+          </a:p>
+        </c:txPr>
+        <c:crossAx val="48650112"/>
+        <c:crossBetween val="between"/>
+        <c:majorUnit val="1"/>
+      </c:valAx>
+      <c:spPr>
+        <a:solidFill xmlns:a="http://schemas.openxmlformats.org/drawingml/2006/main">
+          <a:srgbClr val="FFFFFF"/>
+        </a:solidFill>
+      </c:spPr>
+    </c:plotArea>
+    <c:plotVisOnly val="1"/>
+  </c:chart>
+  <c:spPr>
+    <a:solidFill xmlns:a="http://schemas.openxmlformats.org/drawingml/2006/main">
+      <a:srgbClr val="FFFFFF"/>
+    </a:solidFill>
+  </c:spPr>
+  <c:externalData r:id="rIdChartSnapshot1">
+    <c:autoUpdate val="0"/>
+  </c:externalData>
+</c:chartSpace>
+</file>
+
 <file path=ppt/slides/slide1.xml><?xml version="1.0" encoding="utf-8"?>
 <p:sld xmlns:p="http://schemas.openxmlformats.org/presentationml/2006/main">
   <p:cSld>
@@ -2130,7 +2370,7 @@
           <p:cNvPr id="5" name="">
             <a:extLst xmlns:a="http://schemas.openxmlformats.org/drawingml/2006/main">
               <a:ext uri="{FF2B5EF4-FFF2-40B4-BE49-F238E27FC236}">
-                <a16:creationId xmlns:a16="http://schemas.microsoft.com/office/drawing/2014/main" id="{14E8FBF4-43A9-4E8C-89D5-9870BED3B61B}"/>
+                <a16:creationId xmlns:a16="http://schemas.microsoft.com/office/drawing/2014/main" id="{EEC62430-56CB-4CBD-8ED5-CAB9AB65F493}"/>
               </a:ext>
             </a:extLst>
           </p:cNvPr>
@@ -2141,8 +2381,8 @@
         </p:nvSpPr>
         <p:spPr>
           <a:xfrm xmlns:a="http://schemas.openxmlformats.org/drawingml/2006/main">
-            <a:off x="552450" y="333375"/>
-            <a:ext cx="11049000" cy="857250"/>
+            <a:off x="552450" y="266700"/>
+            <a:ext cx="11049000" cy="742950"/>
           </a:xfrm>
           <a:prstGeom xmlns:a="http://schemas.openxmlformats.org/drawingml/2006/main" prst="rect">
             <a:avLst/>
@@ -2153,13 +2393,13 @@
           </a:ln>
         </p:spPr>
         <p:txBody>
-          <a:bodyPr xmlns:a="http://schemas.openxmlformats.org/drawingml/2006/main">
+          <a:bodyPr xmlns:a="http://schemas.openxmlformats.org/drawingml/2006/main" anchor="ctr">
             <a:noAutofit/>
           </a:bodyPr>
           <a:lstStyle xmlns:a="http://schemas.openxmlformats.org/drawingml/2006/main"/>
           <a:p xmlns:a="http://schemas.openxmlformats.org/drawingml/2006/main">
-            <a:pPr>
-              <a:defRPr sz="3150" b="1">
+            <a:pPr algn="l">
+              <a:defRPr sz="2700" b="1">
                 <a:solidFill>
                   <a:srgbClr val="161616"/>
                 </a:solidFill>
@@ -2169,7 +2409,7 @@
               </a:defRPr>
             </a:pPr>
             <a:r>
-              <a:rPr sz="3150" b="1">
+              <a:rPr sz="2700" b="1">
                 <a:solidFill>
                   <a:srgbClr val="161616"/>
                 </a:solidFill>
@@ -2187,7 +2427,7 @@
           <p:cNvPr id="2" name="">
             <a:extLst xmlns:a="http://schemas.openxmlformats.org/drawingml/2006/main">
               <a:ext uri="{FF2B5EF4-FFF2-40B4-BE49-F238E27FC236}">
-                <a16:creationId xmlns:a16="http://schemas.microsoft.com/office/drawing/2014/main" id="{1A49EA91-EDE0-4687-8CC1-A19A5DFE2B68}"/>
+                <a16:creationId xmlns:a16="http://schemas.microsoft.com/office/drawing/2014/main" id="{BD362F8B-6134-4B8F-AFEB-BE5067529D2E}"/>
               </a:ext>
             </a:extLst>
           </p:cNvPr>
@@ -2244,7 +2484,7 @@
           <p:cNvPr id="3" name="">
             <a:extLst xmlns:a="http://schemas.openxmlformats.org/drawingml/2006/main">
               <a:ext uri="{FF2B5EF4-FFF2-40B4-BE49-F238E27FC236}">
-                <a16:creationId xmlns:a16="http://schemas.microsoft.com/office/drawing/2014/main" id="{1FF03DE3-6E5E-4F2A-A9CB-8020DEFB6F95}"/>
+                <a16:creationId xmlns:a16="http://schemas.microsoft.com/office/drawing/2014/main" id="{4BD1047A-3184-4DE9-A41D-E50C492EF4E7}"/>
               </a:ext>
             </a:extLst>
           </p:cNvPr>
@@ -2301,7 +2541,7 @@
           <p:cNvPr id="4" name="">
             <a:extLst xmlns:a="http://schemas.openxmlformats.org/drawingml/2006/main">
               <a:ext uri="{FF2B5EF4-FFF2-40B4-BE49-F238E27FC236}">
-                <a16:creationId xmlns:a16="http://schemas.microsoft.com/office/drawing/2014/main" id="{1D8A91C7-D3EB-4AC0-B09E-097957A1F207}"/>
+                <a16:creationId xmlns:a16="http://schemas.microsoft.com/office/drawing/2014/main" id="{CC63E662-16EF-4895-AB68-384AFB59FB2F}"/>
               </a:ext>
             </a:extLst>
           </p:cNvPr>
@@ -2379,7 +2619,7 @@
     </p:spTree>
     <p:extLst>
       <p:ext uri="{BB962C8B-B14F-4D97-AF65-F5344CB8AC3E}">
-        <p14:creationId xmlns:p14="http://schemas.microsoft.com/office/powerpoint/2010/main" val="1655409025"/>
+        <p14:creationId xmlns:p14="http://schemas.microsoft.com/office/powerpoint/2010/main" val="1228378915"/>
       </p:ext>
     </p:extLst>
   </p:cSld>
@@ -2410,7 +2650,7 @@
           <p:cNvPr id="10" name="">
             <a:extLst xmlns:a="http://schemas.openxmlformats.org/drawingml/2006/main">
               <a:ext uri="{FF2B5EF4-FFF2-40B4-BE49-F238E27FC236}">
-                <a16:creationId xmlns:a16="http://schemas.microsoft.com/office/drawing/2014/main" id="{F26EA70D-2D06-4C41-9F0B-721E0F241BF7}"/>
+                <a16:creationId xmlns:a16="http://schemas.microsoft.com/office/drawing/2014/main" id="{40E98615-A7F0-43E5-9464-135D8AEED5BF}"/>
               </a:ext>
             </a:extLst>
           </p:cNvPr>
@@ -2421,8 +2661,8 @@
         </p:nvSpPr>
         <p:spPr>
           <a:xfrm xmlns:a="http://schemas.openxmlformats.org/drawingml/2006/main">
-            <a:off x="552450" y="333375"/>
-            <a:ext cx="11049000" cy="857250"/>
+            <a:off x="552450" y="266700"/>
+            <a:ext cx="11049000" cy="742950"/>
           </a:xfrm>
           <a:prstGeom xmlns:a="http://schemas.openxmlformats.org/drawingml/2006/main" prst="rect">
             <a:avLst/>
@@ -2433,13 +2673,13 @@
           </a:ln>
         </p:spPr>
         <p:txBody>
-          <a:bodyPr xmlns:a="http://schemas.openxmlformats.org/drawingml/2006/main">
+          <a:bodyPr xmlns:a="http://schemas.openxmlformats.org/drawingml/2006/main" anchor="ctr">
             <a:noAutofit/>
           </a:bodyPr>
           <a:lstStyle xmlns:a="http://schemas.openxmlformats.org/drawingml/2006/main"/>
           <a:p xmlns:a="http://schemas.openxmlformats.org/drawingml/2006/main">
-            <a:pPr>
-              <a:defRPr sz="3150" b="1">
+            <a:pPr algn="l">
+              <a:defRPr sz="2700" b="1">
                 <a:solidFill>
                   <a:srgbClr val="161616"/>
                 </a:solidFill>
@@ -2449,7 +2689,7 @@
               </a:defRPr>
             </a:pPr>
             <a:r>
-              <a:rPr sz="3150" b="1">
+              <a:rPr sz="2700" b="1">
                 <a:solidFill>
                   <a:srgbClr val="161616"/>
                 </a:solidFill>
@@ -2467,7 +2707,7 @@
           <p:cNvPr id="2" name="">
             <a:extLst xmlns:a="http://schemas.openxmlformats.org/drawingml/2006/main">
               <a:ext uri="{FF2B5EF4-FFF2-40B4-BE49-F238E27FC236}">
-                <a16:creationId xmlns:a16="http://schemas.microsoft.com/office/drawing/2014/main" id="{F47F6705-039C-407E-864A-CE9CA07DABE0}"/>
+                <a16:creationId xmlns:a16="http://schemas.microsoft.com/office/drawing/2014/main" id="{11EC928D-CF6D-465F-A3B2-07AD2417E79B}"/>
               </a:ext>
             </a:extLst>
           </p:cNvPr>
@@ -2514,7 +2754,7 @@
                 <a:ea typeface="Arial"/>
                 <a:cs typeface="Arial"/>
               </a:rPr>
-              <a:t>Производительность</a:t>
+              <a:t>Скорость и доступность</a:t>
             </a:r>
           </a:p>
         </p:txBody>
@@ -2524,7 +2764,7 @@
           <p:cNvPr id="3" name="">
             <a:extLst xmlns:a="http://schemas.openxmlformats.org/drawingml/2006/main">
               <a:ext uri="{FF2B5EF4-FFF2-40B4-BE49-F238E27FC236}">
-                <a16:creationId xmlns:a16="http://schemas.microsoft.com/office/drawing/2014/main" id="{F9283054-F00C-4DA1-9F72-940F369C9D50}"/>
+                <a16:creationId xmlns:a16="http://schemas.microsoft.com/office/drawing/2014/main" id="{8EEB274C-F4CA-4500-9BC4-806B0CD0B3F2}"/>
               </a:ext>
             </a:extLst>
           </p:cNvPr>
@@ -2571,7 +2811,7 @@
                 <a:ea typeface="Arial"/>
                 <a:cs typeface="Arial"/>
               </a:rPr>
-              <a:t>Надёжность</a:t>
+              <a:t>Восстановление и канал</a:t>
             </a:r>
           </a:p>
         </p:txBody>
@@ -2581,7 +2821,7 @@
           <p:cNvPr id="4" name="">
             <a:extLst xmlns:a="http://schemas.openxmlformats.org/drawingml/2006/main">
               <a:ext uri="{FF2B5EF4-FFF2-40B4-BE49-F238E27FC236}">
-                <a16:creationId xmlns:a16="http://schemas.microsoft.com/office/drawing/2014/main" id="{1E2818D9-1830-484E-A04C-B275041530ED}"/>
+                <a16:creationId xmlns:a16="http://schemas.microsoft.com/office/drawing/2014/main" id="{5F99B955-6B96-4995-9296-CB9EC0BE2B8A}"/>
               </a:ext>
             </a:extLst>
           </p:cNvPr>
@@ -2628,7 +2868,7 @@
                 <a:ea typeface="Arial"/>
                 <a:cs typeface="Arial"/>
               </a:rPr>
-              <a:t>NFR-01 Основные формы: до 2 с для 95% запросов.</a:t>
+              <a:t>NFR-01 95% запросов до 2 с, 50 пользователей.</a:t>
             </a:r>
           </a:p>
         </p:txBody>
@@ -2638,7 +2878,7 @@
           <p:cNvPr id="5" name="">
             <a:extLst xmlns:a="http://schemas.openxmlformats.org/drawingml/2006/main">
               <a:ext uri="{FF2B5EF4-FFF2-40B4-BE49-F238E27FC236}">
-                <a16:creationId xmlns:a16="http://schemas.microsoft.com/office/drawing/2014/main" id="{50363743-026C-4A2E-B1F3-2D8FA45284E0}"/>
+                <a16:creationId xmlns:a16="http://schemas.microsoft.com/office/drawing/2014/main" id="{0A0A0C70-8003-4143-854A-E2833641EDFD}"/>
               </a:ext>
             </a:extLst>
           </p:cNvPr>
@@ -2685,7 +2925,7 @@
                 <a:ea typeface="Arial"/>
                 <a:cs typeface="Arial"/>
               </a:rPr>
-              <a:t>NFR-02 Пакетная операция: до 1000 модельных рядов.</a:t>
+              <a:t>NFR-02 Замена и проверка 1000 модельных рядов до 5 мин.</a:t>
             </a:r>
           </a:p>
         </p:txBody>
@@ -2695,7 +2935,7 @@
           <p:cNvPr id="6" name="">
             <a:extLst xmlns:a="http://schemas.openxmlformats.org/drawingml/2006/main">
               <a:ext uri="{FF2B5EF4-FFF2-40B4-BE49-F238E27FC236}">
-                <a16:creationId xmlns:a16="http://schemas.microsoft.com/office/drawing/2014/main" id="{BB3BBB44-0121-425D-BC5A-370640F48412}"/>
+                <a16:creationId xmlns:a16="http://schemas.microsoft.com/office/drawing/2014/main" id="{4DAAEA2F-C100-44DF-B24B-F34F12F85274}"/>
               </a:ext>
             </a:extLst>
           </p:cNvPr>
@@ -2742,7 +2982,7 @@
                 <a:ea typeface="Arial"/>
                 <a:cs typeface="Arial"/>
               </a:rPr>
-              <a:t>NFR-03 Фоновая публикация не блокирует интерфейс.</a:t>
+              <a:t>NFR-03 Доступность за месяц не ниже 99,5%.</a:t>
             </a:r>
           </a:p>
         </p:txBody>
@@ -2752,7 +2992,7 @@
           <p:cNvPr id="7" name="">
             <a:extLst xmlns:a="http://schemas.openxmlformats.org/drawingml/2006/main">
               <a:ext uri="{FF2B5EF4-FFF2-40B4-BE49-F238E27FC236}">
-                <a16:creationId xmlns:a16="http://schemas.microsoft.com/office/drawing/2014/main" id="{A8675D1E-F31E-4E3D-B040-ADB6955AB1A7}"/>
+                <a16:creationId xmlns:a16="http://schemas.microsoft.com/office/drawing/2014/main" id="{0E4DCA2D-2EE2-45BD-885C-4F2EB9E822DD}"/>
               </a:ext>
             </a:extLst>
           </p:cNvPr>
@@ -2799,7 +3039,7 @@
                 <a:ea typeface="Arial"/>
                 <a:cs typeface="Arial"/>
               </a:rPr>
-              <a:t>NFR-04 Контроль целостности версий.</a:t>
+              <a:t>NFR-04 Копии ежедневно. RPO 24 ч, RTO 4 ч.</a:t>
             </a:r>
           </a:p>
         </p:txBody>
@@ -2809,7 +3049,7 @@
           <p:cNvPr id="8" name="">
             <a:extLst xmlns:a="http://schemas.openxmlformats.org/drawingml/2006/main">
               <a:ext uri="{FF2B5EF4-FFF2-40B4-BE49-F238E27FC236}">
-                <a16:creationId xmlns:a16="http://schemas.microsoft.com/office/drawing/2014/main" id="{9A484614-0AC3-43E2-96E2-53DF35BF9035}"/>
+                <a16:creationId xmlns:a16="http://schemas.microsoft.com/office/drawing/2014/main" id="{DACD82CE-2A2F-44C1-96F0-8DE47BB71B7D}"/>
               </a:ext>
             </a:extLst>
           </p:cNvPr>
@@ -2856,7 +3096,7 @@
                 <a:ea typeface="Arial"/>
                 <a:cs typeface="Arial"/>
               </a:rPr>
-              <a:t>NFR-05 Резервное копирование и проверка восстановления.</a:t>
+              <a:t>NFR-05 TLS 1.2 или новее.</a:t>
             </a:r>
           </a:p>
         </p:txBody>
@@ -2866,7 +3106,7 @@
           <p:cNvPr id="9" name="">
             <a:extLst xmlns:a="http://schemas.openxmlformats.org/drawingml/2006/main">
               <a:ext uri="{FF2B5EF4-FFF2-40B4-BE49-F238E27FC236}">
-                <a16:creationId xmlns:a16="http://schemas.microsoft.com/office/drawing/2014/main" id="{AF9240DB-4AAD-400A-9D8D-BD6EFAC02B98}"/>
+                <a16:creationId xmlns:a16="http://schemas.microsoft.com/office/drawing/2014/main" id="{AA393378-AFF7-4375-8A0F-E997094315A7}"/>
               </a:ext>
             </a:extLst>
           </p:cNvPr>
@@ -2913,7 +3153,7 @@
                 <a:ea typeface="Arial"/>
                 <a:cs typeface="Arial"/>
               </a:rPr>
-              <a:t>Пороговые значения проверяются после реализации.</a:t>
+              <a:t>Пороговые значения требуют испытаний.</a:t>
             </a:r>
           </a:p>
         </p:txBody>
@@ -2921,7 +3161,7 @@
     </p:spTree>
     <p:extLst>
       <p:ext uri="{BB962C8B-B14F-4D97-AF65-F5344CB8AC3E}">
-        <p14:creationId xmlns:p14="http://schemas.microsoft.com/office/powerpoint/2010/main" val="2131275085"/>
+        <p14:creationId xmlns:p14="http://schemas.microsoft.com/office/powerpoint/2010/main" val="1491967892"/>
       </p:ext>
     </p:extLst>
   </p:cSld>
@@ -2949,10 +3189,10 @@
       </p:grpSpPr>
       <p:sp>
         <p:nvSpPr>
-          <p:cNvPr id="12" name="">
+          <p:cNvPr id="14" name="">
             <a:extLst xmlns:a="http://schemas.openxmlformats.org/drawingml/2006/main">
               <a:ext uri="{FF2B5EF4-FFF2-40B4-BE49-F238E27FC236}">
-                <a16:creationId xmlns:a16="http://schemas.microsoft.com/office/drawing/2014/main" id="{3D912495-CE88-4A51-AE2B-7429B61E72C8}"/>
+                <a16:creationId xmlns:a16="http://schemas.microsoft.com/office/drawing/2014/main" id="{75409D8D-A165-44F2-838F-F89AE5B27CC6}"/>
               </a:ext>
             </a:extLst>
           </p:cNvPr>
@@ -2963,8 +3203,8 @@
         </p:nvSpPr>
         <p:spPr>
           <a:xfrm xmlns:a="http://schemas.openxmlformats.org/drawingml/2006/main">
-            <a:off x="552450" y="333375"/>
-            <a:ext cx="11049000" cy="857250"/>
+            <a:off x="552450" y="266700"/>
+            <a:ext cx="11049000" cy="742950"/>
           </a:xfrm>
           <a:prstGeom xmlns:a="http://schemas.openxmlformats.org/drawingml/2006/main" prst="rect">
             <a:avLst/>
@@ -2975,13 +3215,13 @@
           </a:ln>
         </p:spPr>
         <p:txBody>
-          <a:bodyPr xmlns:a="http://schemas.openxmlformats.org/drawingml/2006/main">
+          <a:bodyPr xmlns:a="http://schemas.openxmlformats.org/drawingml/2006/main" anchor="ctr">
             <a:noAutofit/>
           </a:bodyPr>
           <a:lstStyle xmlns:a="http://schemas.openxmlformats.org/drawingml/2006/main"/>
           <a:p xmlns:a="http://schemas.openxmlformats.org/drawingml/2006/main">
-            <a:pPr>
-              <a:defRPr sz="3150" b="1">
+            <a:pPr algn="l">
+              <a:defRPr sz="2700" b="1">
                 <a:solidFill>
                   <a:srgbClr val="161616"/>
                 </a:solidFill>
@@ -2991,7 +3231,7 @@
               </a:defRPr>
             </a:pPr>
             <a:r>
-              <a:rPr sz="3150" b="1">
+              <a:rPr sz="2700" b="1">
                 <a:solidFill>
                   <a:srgbClr val="161616"/>
                 </a:solidFill>
@@ -3009,7 +3249,7 @@
           <p:cNvPr id="2" name="">
             <a:extLst xmlns:a="http://schemas.openxmlformats.org/drawingml/2006/main">
               <a:ext uri="{FF2B5EF4-FFF2-40B4-BE49-F238E27FC236}">
-                <a16:creationId xmlns:a16="http://schemas.microsoft.com/office/drawing/2014/main" id="{F6EE8767-1ABF-45D2-8EEE-73468830A630}"/>
+                <a16:creationId xmlns:a16="http://schemas.microsoft.com/office/drawing/2014/main" id="{A46DB4F8-C1E1-4B5E-82A3-7EC7F222372F}"/>
               </a:ext>
             </a:extLst>
           </p:cNvPr>
@@ -3056,7 +3296,7 @@
                 <a:ea typeface="Arial"/>
                 <a:cs typeface="Arial"/>
               </a:rPr>
-              <a:t>Защита и доступ</a:t>
+              <a:t>Защита и совместимость</a:t>
             </a:r>
           </a:p>
         </p:txBody>
@@ -3066,7 +3306,7 @@
           <p:cNvPr id="3" name="">
             <a:extLst xmlns:a="http://schemas.openxmlformats.org/drawingml/2006/main">
               <a:ext uri="{FF2B5EF4-FFF2-40B4-BE49-F238E27FC236}">
-                <a16:creationId xmlns:a16="http://schemas.microsoft.com/office/drawing/2014/main" id="{8157FA0B-8A03-4196-8911-CD5BFCDF17A6}"/>
+                <a16:creationId xmlns:a16="http://schemas.microsoft.com/office/drawing/2014/main" id="{F7E1E00F-9404-4C14-BEB2-1558C9CC4C8E}"/>
               </a:ext>
             </a:extLst>
           </p:cNvPr>
@@ -3113,7 +3353,7 @@
                 <a:ea typeface="Arial"/>
                 <a:cs typeface="Arial"/>
               </a:rPr>
-              <a:t>Эксплуатация</a:t>
+              <a:t>Интеграции и целостность</a:t>
             </a:r>
           </a:p>
         </p:txBody>
@@ -3123,7 +3363,7 @@
           <p:cNvPr id="4" name="">
             <a:extLst xmlns:a="http://schemas.openxmlformats.org/drawingml/2006/main">
               <a:ext uri="{FF2B5EF4-FFF2-40B4-BE49-F238E27FC236}">
-                <a16:creationId xmlns:a16="http://schemas.microsoft.com/office/drawing/2014/main" id="{0DBDFC23-E66F-4078-8D89-67729E056310}"/>
+                <a16:creationId xmlns:a16="http://schemas.microsoft.com/office/drawing/2014/main" id="{38664A52-CD35-4238-A9B1-125B92542681}"/>
               </a:ext>
             </a:extLst>
           </p:cNvPr>
@@ -3170,7 +3410,7 @@
                 <a:ea typeface="Arial"/>
                 <a:cs typeface="Arial"/>
               </a:rPr>
-              <a:t>NFR-06 Индивидуальная аутентификация.</a:t>
+              <a:t>NFR-06 Argon2id и уникальная соль.</a:t>
             </a:r>
           </a:p>
         </p:txBody>
@@ -3180,7 +3420,7 @@
           <p:cNvPr id="5" name="">
             <a:extLst xmlns:a="http://schemas.openxmlformats.org/drawingml/2006/main">
               <a:ext uri="{FF2B5EF4-FFF2-40B4-BE49-F238E27FC236}">
-                <a16:creationId xmlns:a16="http://schemas.microsoft.com/office/drawing/2014/main" id="{B9F4577E-D567-45BA-B36A-3D9912B6161E}"/>
+                <a16:creationId xmlns:a16="http://schemas.microsoft.com/office/drawing/2014/main" id="{C320DFB2-4475-491F-941B-B32CD4B17574}"/>
               </a:ext>
             </a:extLst>
           </p:cNvPr>
@@ -3237,7 +3477,7 @@
           <p:cNvPr id="6" name="">
             <a:extLst xmlns:a="http://schemas.openxmlformats.org/drawingml/2006/main">
               <a:ext uri="{FF2B5EF4-FFF2-40B4-BE49-F238E27FC236}">
-                <a16:creationId xmlns:a16="http://schemas.microsoft.com/office/drawing/2014/main" id="{25AB98C1-8EDC-44F0-8D0C-EC85098D0D3C}"/>
+                <a16:creationId xmlns:a16="http://schemas.microsoft.com/office/drawing/2014/main" id="{70C81202-9EAD-4A0E-910F-FFA3FD0DB77D}"/>
               </a:ext>
             </a:extLst>
           </p:cNvPr>
@@ -3284,7 +3524,7 @@
                 <a:ea typeface="Arial"/>
                 <a:cs typeface="Arial"/>
               </a:rPr>
-              <a:t>NFR-08 Аудит действий.</a:t>
+              <a:t>NFR-08 Аудит хранится не менее года.</a:t>
             </a:r>
           </a:p>
         </p:txBody>
@@ -3294,7 +3534,7 @@
           <p:cNvPr id="7" name="">
             <a:extLst xmlns:a="http://schemas.openxmlformats.org/drawingml/2006/main">
               <a:ext uri="{FF2B5EF4-FFF2-40B4-BE49-F238E27FC236}">
-                <a16:creationId xmlns:a16="http://schemas.microsoft.com/office/drawing/2014/main" id="{C7D1BAFC-86BE-4DAA-A80C-49B35FB9C044}"/>
+                <a16:creationId xmlns:a16="http://schemas.microsoft.com/office/drawing/2014/main" id="{F572D7A7-5EBA-4109-AEBC-8A78D25199B8}"/>
               </a:ext>
             </a:extLst>
           </p:cNvPr>
@@ -3341,7 +3581,7 @@
                 <a:ea typeface="Arial"/>
                 <a:cs typeface="Arial"/>
               </a:rPr>
-              <a:t>NFR-09 TLS и защита секретов.</a:t>
+              <a:t>NFR-09 Две версии Chrome, Edge, Firefox.</a:t>
             </a:r>
           </a:p>
         </p:txBody>
@@ -3351,7 +3591,64 @@
           <p:cNvPr id="8" name="">
             <a:extLst xmlns:a="http://schemas.openxmlformats.org/drawingml/2006/main">
               <a:ext uri="{FF2B5EF4-FFF2-40B4-BE49-F238E27FC236}">
-                <a16:creationId xmlns:a16="http://schemas.microsoft.com/office/drawing/2014/main" id="{D1ACF373-C657-49C8-84CB-50502F3E5219}"/>
+                <a16:creationId xmlns:a16="http://schemas.microsoft.com/office/drawing/2014/main" id="{DC05FAE6-E947-41A1-A8E5-0045CA5810E7}"/>
+              </a:ext>
+            </a:extLst>
+          </p:cNvPr>
+          <p:cNvSpPr>
+            <a:spLocks xmlns:a="http://schemas.openxmlformats.org/drawingml/2006/main" noGrp="1"/>
+          </p:cNvSpPr>
+          <p:nvPr/>
+        </p:nvSpPr>
+        <p:spPr>
+          <a:xfrm xmlns:a="http://schemas.openxmlformats.org/drawingml/2006/main">
+            <a:off x="666750" y="4686300"/>
+            <a:ext cx="4953000" cy="552450"/>
+          </a:xfrm>
+          <a:prstGeom xmlns:a="http://schemas.openxmlformats.org/drawingml/2006/main" prst="rect">
+            <a:avLst/>
+          </a:prstGeom>
+          <a:noFill xmlns:a="http://schemas.openxmlformats.org/drawingml/2006/main"/>
+          <a:ln xmlns:a="http://schemas.openxmlformats.org/drawingml/2006/main" w="0">
+            <a:noFill/>
+          </a:ln>
+        </p:spPr>
+        <p:txBody>
+          <a:bodyPr xmlns:a="http://schemas.openxmlformats.org/drawingml/2006/main">
+            <a:noAutofit/>
+          </a:bodyPr>
+          <a:lstStyle xmlns:a="http://schemas.openxmlformats.org/drawingml/2006/main"/>
+          <a:p xmlns:a="http://schemas.openxmlformats.org/drawingml/2006/main">
+            <a:pPr>
+              <a:defRPr sz="1650" b="0">
+                <a:solidFill>
+                  <a:srgbClr val="161616"/>
+                </a:solidFill>
+                <a:latin typeface="Arial"/>
+                <a:ea typeface="Arial"/>
+                <a:cs typeface="Arial"/>
+              </a:defRPr>
+            </a:pPr>
+            <a:r>
+              <a:rPr sz="1650" b="0">
+                <a:solidFill>
+                  <a:srgbClr val="161616"/>
+                </a:solidFill>
+                <a:latin typeface="Arial"/>
+                <a:ea typeface="Arial"/>
+                <a:cs typeface="Arial"/>
+              </a:rPr>
+              <a:t>Ширина интерфейса от 1280 пикселей.</a:t>
+            </a:r>
+          </a:p>
+        </p:txBody>
+      </p:sp>
+      <p:sp>
+        <p:nvSpPr>
+          <p:cNvPr id="9" name="">
+            <a:extLst xmlns:a="http://schemas.openxmlformats.org/drawingml/2006/main">
+              <a:ext uri="{FF2B5EF4-FFF2-40B4-BE49-F238E27FC236}">
+                <a16:creationId xmlns:a16="http://schemas.microsoft.com/office/drawing/2014/main" id="{B8B92CA7-91B4-43BE-9F04-053A75B74B68}"/>
               </a:ext>
             </a:extLst>
           </p:cNvPr>
@@ -3398,17 +3695,17 @@
                 <a:ea typeface="Arial"/>
                 <a:cs typeface="Arial"/>
               </a:rPr>
-              <a:t>NFR-10 Обработка ошибок интеграций.</a:t>
-            </a:r>
-          </a:p>
-        </p:txBody>
-      </p:sp>
-      <p:sp>
-        <p:nvSpPr>
-          <p:cNvPr id="9" name="">
+              <a:t>NFR-10 До трёх повторов без дубликатов.</a:t>
+            </a:r>
+          </a:p>
+        </p:txBody>
+      </p:sp>
+      <p:sp>
+        <p:nvSpPr>
+          <p:cNvPr id="10" name="">
             <a:extLst xmlns:a="http://schemas.openxmlformats.org/drawingml/2006/main">
               <a:ext uri="{FF2B5EF4-FFF2-40B4-BE49-F238E27FC236}">
-                <a16:creationId xmlns:a16="http://schemas.microsoft.com/office/drawing/2014/main" id="{C9181753-8193-4DA7-9E91-C5C9A63AA228}"/>
+                <a16:creationId xmlns:a16="http://schemas.microsoft.com/office/drawing/2014/main" id="{0B6A1D9C-9A4B-4A97-BED7-B95200B3624E}"/>
               </a:ext>
             </a:extLst>
           </p:cNvPr>
@@ -3455,17 +3752,17 @@
                 <a:ea typeface="Arial"/>
                 <a:cs typeface="Arial"/>
               </a:rPr>
-              <a:t>NFR-11 Наблюдаемость и уведомления.</a:t>
-            </a:r>
-          </a:p>
-        </p:txBody>
-      </p:sp>
-      <p:sp>
-        <p:nvSpPr>
-          <p:cNvPr id="10" name="">
+              <a:t>Неизвестный результат сначала сверяется.</a:t>
+            </a:r>
+          </a:p>
+        </p:txBody>
+      </p:sp>
+      <p:sp>
+        <p:nvSpPr>
+          <p:cNvPr id="11" name="">
             <a:extLst xmlns:a="http://schemas.openxmlformats.org/drawingml/2006/main">
               <a:ext uri="{FF2B5EF4-FFF2-40B4-BE49-F238E27FC236}">
-                <a16:creationId xmlns:a16="http://schemas.microsoft.com/office/drawing/2014/main" id="{E5774882-BCCD-490E-B5B5-FD12AC772AB9}"/>
+                <a16:creationId xmlns:a16="http://schemas.microsoft.com/office/drawing/2014/main" id="{0561D7DF-EE7C-4049-83F0-D473A73A5C62}"/>
               </a:ext>
             </a:extLst>
           </p:cNvPr>
@@ -3512,17 +3809,17 @@
                 <a:ea typeface="Arial"/>
                 <a:cs typeface="Arial"/>
               </a:rPr>
-              <a:t>NFR-12 Расширяемые адаптеры и правила.</a:t>
-            </a:r>
-          </a:p>
-        </p:txBody>
-      </p:sp>
-      <p:sp>
-        <p:nvSpPr>
-          <p:cNvPr id="11" name="">
+              <a:t>NFR-11 READY только при корректных данных.</a:t>
+            </a:r>
+          </a:p>
+        </p:txBody>
+      </p:sp>
+      <p:sp>
+        <p:nvSpPr>
+          <p:cNvPr id="12" name="">
             <a:extLst xmlns:a="http://schemas.openxmlformats.org/drawingml/2006/main">
               <a:ext uri="{FF2B5EF4-FFF2-40B4-BE49-F238E27FC236}">
-                <a16:creationId xmlns:a16="http://schemas.microsoft.com/office/drawing/2014/main" id="{3ECDF378-F038-42E9-B804-6415E2274A1F}"/>
+                <a16:creationId xmlns:a16="http://schemas.microsoft.com/office/drawing/2014/main" id="{428468C9-04E6-4605-B7E3-74B2A40F55D9}"/>
               </a:ext>
             </a:extLst>
           </p:cNvPr>
@@ -3569,7 +3866,64 @@
                 <a:ea typeface="Arial"/>
                 <a:cs typeface="Arial"/>
               </a:rPr>
-              <a:t>Требования служат критериями будущей приёмки.</a:t>
+              <a:t>NFR-12 Правила меняются без правки кода.</a:t>
+            </a:r>
+          </a:p>
+        </p:txBody>
+      </p:sp>
+      <p:sp>
+        <p:nvSpPr>
+          <p:cNvPr id="13" name="">
+            <a:extLst xmlns:a="http://schemas.openxmlformats.org/drawingml/2006/main">
+              <a:ext uri="{FF2B5EF4-FFF2-40B4-BE49-F238E27FC236}">
+                <a16:creationId xmlns:a16="http://schemas.microsoft.com/office/drawing/2014/main" id="{A84240CC-EC05-45EC-B614-C9BE2562E24F}"/>
+              </a:ext>
+            </a:extLst>
+          </p:cNvPr>
+          <p:cNvSpPr>
+            <a:spLocks xmlns:a="http://schemas.openxmlformats.org/drawingml/2006/main" noGrp="1"/>
+          </p:cNvSpPr>
+          <p:nvPr/>
+        </p:nvSpPr>
+        <p:spPr>
+          <a:xfrm xmlns:a="http://schemas.openxmlformats.org/drawingml/2006/main">
+            <a:off x="6572250" y="4686300"/>
+            <a:ext cx="4953000" cy="552450"/>
+          </a:xfrm>
+          <a:prstGeom xmlns:a="http://schemas.openxmlformats.org/drawingml/2006/main" prst="rect">
+            <a:avLst/>
+          </a:prstGeom>
+          <a:noFill xmlns:a="http://schemas.openxmlformats.org/drawingml/2006/main"/>
+          <a:ln xmlns:a="http://schemas.openxmlformats.org/drawingml/2006/main" w="0">
+            <a:noFill/>
+          </a:ln>
+        </p:spPr>
+        <p:txBody>
+          <a:bodyPr xmlns:a="http://schemas.openxmlformats.org/drawingml/2006/main">
+            <a:noAutofit/>
+          </a:bodyPr>
+          <a:lstStyle xmlns:a="http://schemas.openxmlformats.org/drawingml/2006/main"/>
+          <a:p xmlns:a="http://schemas.openxmlformats.org/drawingml/2006/main">
+            <a:pPr>
+              <a:defRPr sz="1650" b="0">
+                <a:solidFill>
+                  <a:srgbClr val="161616"/>
+                </a:solidFill>
+                <a:latin typeface="Arial"/>
+                <a:ea typeface="Arial"/>
+                <a:cs typeface="Arial"/>
+              </a:defRPr>
+            </a:pPr>
+            <a:r>
+              <a:rPr sz="1650" b="0">
+                <a:solidFill>
+                  <a:srgbClr val="161616"/>
+                </a:solidFill>
+                <a:latin typeface="Arial"/>
+                <a:ea typeface="Arial"/>
+                <a:cs typeface="Arial"/>
+              </a:rPr>
+              <a:t>Требования служат критериями приёмки.</a:t>
             </a:r>
           </a:p>
         </p:txBody>
@@ -3577,7 +3931,7 @@
     </p:spTree>
     <p:extLst>
       <p:ext uri="{BB962C8B-B14F-4D97-AF65-F5344CB8AC3E}">
-        <p14:creationId xmlns:p14="http://schemas.microsoft.com/office/powerpoint/2010/main" val="673174266"/>
+        <p14:creationId xmlns:p14="http://schemas.microsoft.com/office/powerpoint/2010/main" val="2047830436"/>
       </p:ext>
     </p:extLst>
   </p:cSld>
@@ -3608,7 +3962,7 @@
           <p:cNvPr id="3" name="">
             <a:extLst xmlns:a="http://schemas.openxmlformats.org/drawingml/2006/main">
               <a:ext uri="{FF2B5EF4-FFF2-40B4-BE49-F238E27FC236}">
-                <a16:creationId xmlns:a16="http://schemas.microsoft.com/office/drawing/2014/main" id="{29573852-6E55-4BA1-AB6A-FE9C69F120A0}"/>
+                <a16:creationId xmlns:a16="http://schemas.microsoft.com/office/drawing/2014/main" id="{05663DAE-2197-4B97-BF50-4A2F9436E8E6}"/>
               </a:ext>
             </a:extLst>
           </p:cNvPr>
@@ -3619,8 +3973,8 @@
         </p:nvSpPr>
         <p:spPr>
           <a:xfrm xmlns:a="http://schemas.openxmlformats.org/drawingml/2006/main">
-            <a:off x="552450" y="333375"/>
-            <a:ext cx="11049000" cy="857250"/>
+            <a:off x="552450" y="266700"/>
+            <a:ext cx="11049000" cy="742950"/>
           </a:xfrm>
           <a:prstGeom xmlns:a="http://schemas.openxmlformats.org/drawingml/2006/main" prst="rect">
             <a:avLst/>
@@ -3631,13 +3985,13 @@
           </a:ln>
         </p:spPr>
         <p:txBody>
-          <a:bodyPr xmlns:a="http://schemas.openxmlformats.org/drawingml/2006/main">
+          <a:bodyPr xmlns:a="http://schemas.openxmlformats.org/drawingml/2006/main" anchor="ctr">
             <a:noAutofit/>
           </a:bodyPr>
           <a:lstStyle xmlns:a="http://schemas.openxmlformats.org/drawingml/2006/main"/>
           <a:p xmlns:a="http://schemas.openxmlformats.org/drawingml/2006/main">
-            <a:pPr>
-              <a:defRPr sz="3150" b="1">
+            <a:pPr algn="l">
+              <a:defRPr sz="2700" b="1">
                 <a:solidFill>
                   <a:srgbClr val="161616"/>
                 </a:solidFill>
@@ -3647,7 +4001,7 @@
               </a:defRPr>
             </a:pPr>
             <a:r>
-              <a:rPr sz="3150" b="1">
+              <a:rPr sz="2700" b="1">
                 <a:solidFill>
                   <a:srgbClr val="161616"/>
                 </a:solidFill>
@@ -3682,7 +4036,7 @@
                 <a:gridCol w="1619250"/>
                 <a:gridCol w="1524000"/>
               </a:tblGrid>
-              <a:tr h="583406">
+              <a:tr h="424295">
                 <a:tc>
                   <a:txBody>
                     <a:bodyPr/>
@@ -3828,7 +4182,7 @@
                   </a:tcPr>
                 </a:tc>
               </a:tr>
-              <a:tr h="583406">
+              <a:tr h="424295">
                 <a:tc>
                   <a:txBody>
                     <a:bodyPr/>
@@ -3974,7 +4328,7 @@
                   </a:tcPr>
                 </a:tc>
               </a:tr>
-              <a:tr h="583406">
+              <a:tr h="424295">
                 <a:tc>
                   <a:txBody>
                     <a:bodyPr/>
@@ -4120,7 +4474,7 @@
                   </a:tcPr>
                 </a:tc>
               </a:tr>
-              <a:tr h="583406">
+              <a:tr h="424295">
                 <a:tc>
                   <a:txBody>
                     <a:bodyPr/>
@@ -4266,7 +4620,153 @@
                   </a:tcPr>
                 </a:tc>
               </a:tr>
-              <a:tr h="583406">
+              <a:tr h="424295">
+                <a:tc>
+                  <a:txBody>
+                    <a:bodyPr/>
+                    <a:lstStyle/>
+                    <a:p>
+                      <a:r>
+                        <a:rPr sz="1500" b="0">
+                          <a:solidFill>
+                            <a:srgbClr val="161616"/>
+                          </a:solidFill>
+                          <a:latin typeface="Arial"/>
+                          <a:ea typeface="Arial"/>
+                          <a:cs typeface="Arial"/>
+                        </a:rPr>
+                        <a:t>Динамические цены</a:t>
+                      </a:r>
+                    </a:p>
+                  </a:txBody>
+                  <a:tcPr marL="91440" marR="91440" marT="45720" marB="45720">
+                    <a:solidFill>
+                      <a:srgbClr val="FFFFFF"/>
+                    </a:solidFill>
+                  </a:tcPr>
+                </a:tc>
+                <a:tc>
+                  <a:txBody>
+                    <a:bodyPr/>
+                    <a:lstStyle/>
+                    <a:p>
+                      <a:r>
+                        <a:rPr sz="1500" b="0">
+                          <a:solidFill>
+                            <a:srgbClr val="161616"/>
+                          </a:solidFill>
+                          <a:latin typeface="Arial"/>
+                          <a:ea typeface="Arial"/>
+                          <a:cs typeface="Arial"/>
+                        </a:rPr>
+                        <a:t>3</a:t>
+                      </a:r>
+                    </a:p>
+                  </a:txBody>
+                  <a:tcPr marL="91440" marR="91440" marT="45720" marB="45720">
+                    <a:solidFill>
+                      <a:srgbClr val="FFFFFF"/>
+                    </a:solidFill>
+                  </a:tcPr>
+                </a:tc>
+                <a:tc>
+                  <a:txBody>
+                    <a:bodyPr/>
+                    <a:lstStyle/>
+                    <a:p>
+                      <a:r>
+                        <a:rPr sz="1500" b="0">
+                          <a:solidFill>
+                            <a:srgbClr val="161616"/>
+                          </a:solidFill>
+                          <a:latin typeface="Arial"/>
+                          <a:ea typeface="Arial"/>
+                          <a:cs typeface="Arial"/>
+                        </a:rPr>
+                        <a:t>5</a:t>
+                      </a:r>
+                    </a:p>
+                  </a:txBody>
+                  <a:tcPr marL="91440" marR="91440" marT="45720" marB="45720">
+                    <a:solidFill>
+                      <a:srgbClr val="FFFFFF"/>
+                    </a:solidFill>
+                  </a:tcPr>
+                </a:tc>
+                <a:tc>
+                  <a:txBody>
+                    <a:bodyPr/>
+                    <a:lstStyle/>
+                    <a:p>
+                      <a:r>
+                        <a:rPr sz="1500" b="0">
+                          <a:solidFill>
+                            <a:srgbClr val="161616"/>
+                          </a:solidFill>
+                          <a:latin typeface="Arial"/>
+                          <a:ea typeface="Arial"/>
+                          <a:cs typeface="Arial"/>
+                        </a:rPr>
+                        <a:t>3</a:t>
+                      </a:r>
+                    </a:p>
+                  </a:txBody>
+                  <a:tcPr marL="91440" marR="91440" marT="45720" marB="45720">
+                    <a:solidFill>
+                      <a:srgbClr val="FFFFFF"/>
+                    </a:solidFill>
+                  </a:tcPr>
+                </a:tc>
+                <a:tc>
+                  <a:txBody>
+                    <a:bodyPr/>
+                    <a:lstStyle/>
+                    <a:p>
+                      <a:r>
+                        <a:rPr sz="1500" b="0">
+                          <a:solidFill>
+                            <a:srgbClr val="161616"/>
+                          </a:solidFill>
+                          <a:latin typeface="Arial"/>
+                          <a:ea typeface="Arial"/>
+                          <a:cs typeface="Arial"/>
+                        </a:rPr>
+                        <a:t>2</a:t>
+                      </a:r>
+                    </a:p>
+                  </a:txBody>
+                  <a:tcPr marL="91440" marR="91440" marT="45720" marB="45720">
+                    <a:solidFill>
+                      <a:srgbClr val="FFFFFF"/>
+                    </a:solidFill>
+                  </a:tcPr>
+                </a:tc>
+                <a:tc>
+                  <a:txBody>
+                    <a:bodyPr/>
+                    <a:lstStyle/>
+                    <a:p>
+                      <a:r>
+                        <a:rPr sz="1500" b="0">
+                          <a:solidFill>
+                            <a:srgbClr val="161616"/>
+                          </a:solidFill>
+                          <a:latin typeface="Arial"/>
+                          <a:ea typeface="Arial"/>
+                          <a:cs typeface="Arial"/>
+                        </a:rPr>
+                        <a:t>5</a:t>
+                      </a:r>
+                    </a:p>
+                  </a:txBody>
+                  <a:tcPr marL="91440" marR="91440" marT="45720" marB="45720">
+                    <a:solidFill>
+                      <a:srgbClr val="FFFFFF"/>
+                    </a:solidFill>
+                  </a:tcPr>
+                </a:tc>
+              </a:tr>
+              <a:tr h="424295">
                 <a:tc>
                   <a:txBody>
                     <a:bodyPr/>
@@ -4412,7 +4912,7 @@
                   </a:tcPr>
                 </a:tc>
               </a:tr>
-              <a:tr h="583406">
+              <a:tr h="424295">
                 <a:tc>
                   <a:txBody>
                     <a:bodyPr/>
@@ -4558,7 +5058,7 @@
                   </a:tcPr>
                 </a:tc>
               </a:tr>
-              <a:tr h="583406">
+              <a:tr h="424295">
                 <a:tc>
                   <a:txBody>
                     <a:bodyPr/>
@@ -4704,7 +5204,299 @@
                   </a:tcPr>
                 </a:tc>
               </a:tr>
-              <a:tr h="583406">
+              <a:tr h="424295">
+                <a:tc>
+                  <a:txBody>
+                    <a:bodyPr/>
+                    <a:lstStyle/>
+                    <a:p>
+                      <a:r>
+                        <a:rPr sz="1500" b="0">
+                          <a:solidFill>
+                            <a:srgbClr val="161616"/>
+                          </a:solidFill>
+                          <a:latin typeface="Arial"/>
+                          <a:ea typeface="Arial"/>
+                          <a:cs typeface="Arial"/>
+                        </a:rPr>
+                        <a:t>Аудит</a:t>
+                      </a:r>
+                    </a:p>
+                  </a:txBody>
+                  <a:tcPr marL="91440" marR="91440" marT="45720" marB="45720">
+                    <a:solidFill>
+                      <a:srgbClr val="FFFFFF"/>
+                    </a:solidFill>
+                  </a:tcPr>
+                </a:tc>
+                <a:tc>
+                  <a:txBody>
+                    <a:bodyPr/>
+                    <a:lstStyle/>
+                    <a:p>
+                      <a:r>
+                        <a:rPr sz="1500" b="0">
+                          <a:solidFill>
+                            <a:srgbClr val="161616"/>
+                          </a:solidFill>
+                          <a:latin typeface="Arial"/>
+                          <a:ea typeface="Arial"/>
+                          <a:cs typeface="Arial"/>
+                        </a:rPr>
+                        <a:t>2</a:t>
+                      </a:r>
+                    </a:p>
+                  </a:txBody>
+                  <a:tcPr marL="91440" marR="91440" marT="45720" marB="45720">
+                    <a:solidFill>
+                      <a:srgbClr val="FFFFFF"/>
+                    </a:solidFill>
+                  </a:tcPr>
+                </a:tc>
+                <a:tc>
+                  <a:txBody>
+                    <a:bodyPr/>
+                    <a:lstStyle/>
+                    <a:p>
+                      <a:r>
+                        <a:rPr sz="1500" b="0">
+                          <a:solidFill>
+                            <a:srgbClr val="161616"/>
+                          </a:solidFill>
+                          <a:latin typeface="Arial"/>
+                          <a:ea typeface="Arial"/>
+                          <a:cs typeface="Arial"/>
+                        </a:rPr>
+                        <a:t>5</a:t>
+                      </a:r>
+                    </a:p>
+                  </a:txBody>
+                  <a:tcPr marL="91440" marR="91440" marT="45720" marB="45720">
+                    <a:solidFill>
+                      <a:srgbClr val="FFFFFF"/>
+                    </a:solidFill>
+                  </a:tcPr>
+                </a:tc>
+                <a:tc>
+                  <a:txBody>
+                    <a:bodyPr/>
+                    <a:lstStyle/>
+                    <a:p>
+                      <a:r>
+                        <a:rPr sz="1500" b="0">
+                          <a:solidFill>
+                            <a:srgbClr val="161616"/>
+                          </a:solidFill>
+                          <a:latin typeface="Arial"/>
+                          <a:ea typeface="Arial"/>
+                          <a:cs typeface="Arial"/>
+                        </a:rPr>
+                        <a:t>5</a:t>
+                      </a:r>
+                    </a:p>
+                  </a:txBody>
+                  <a:tcPr marL="91440" marR="91440" marT="45720" marB="45720">
+                    <a:solidFill>
+                      <a:srgbClr val="FFFFFF"/>
+                    </a:solidFill>
+                  </a:tcPr>
+                </a:tc>
+                <a:tc>
+                  <a:txBody>
+                    <a:bodyPr/>
+                    <a:lstStyle/>
+                    <a:p>
+                      <a:r>
+                        <a:rPr sz="1500" b="0">
+                          <a:solidFill>
+                            <a:srgbClr val="161616"/>
+                          </a:solidFill>
+                          <a:latin typeface="Arial"/>
+                          <a:ea typeface="Arial"/>
+                          <a:cs typeface="Arial"/>
+                        </a:rPr>
+                        <a:t>4</a:t>
+                      </a:r>
+                    </a:p>
+                  </a:txBody>
+                  <a:tcPr marL="91440" marR="91440" marT="45720" marB="45720">
+                    <a:solidFill>
+                      <a:srgbClr val="FFFFFF"/>
+                    </a:solidFill>
+                  </a:tcPr>
+                </a:tc>
+                <a:tc>
+                  <a:txBody>
+                    <a:bodyPr/>
+                    <a:lstStyle/>
+                    <a:p>
+                      <a:r>
+                        <a:rPr sz="1500" b="0">
+                          <a:solidFill>
+                            <a:srgbClr val="161616"/>
+                          </a:solidFill>
+                          <a:latin typeface="Arial"/>
+                          <a:ea typeface="Arial"/>
+                          <a:cs typeface="Arial"/>
+                        </a:rPr>
+                        <a:t>5</a:t>
+                      </a:r>
+                    </a:p>
+                  </a:txBody>
+                  <a:tcPr marL="91440" marR="91440" marT="45720" marB="45720">
+                    <a:solidFill>
+                      <a:srgbClr val="FFFFFF"/>
+                    </a:solidFill>
+                  </a:tcPr>
+                </a:tc>
+              </a:tr>
+              <a:tr h="424295">
+                <a:tc>
+                  <a:txBody>
+                    <a:bodyPr/>
+                    <a:lstStyle/>
+                    <a:p>
+                      <a:r>
+                        <a:rPr sz="1500" b="0">
+                          <a:solidFill>
+                            <a:srgbClr val="161616"/>
+                          </a:solidFill>
+                          <a:latin typeface="Arial"/>
+                          <a:ea typeface="Arial"/>
+                          <a:cs typeface="Arial"/>
+                        </a:rPr>
+                        <a:t>Расширяемость</a:t>
+                      </a:r>
+                    </a:p>
+                  </a:txBody>
+                  <a:tcPr marL="91440" marR="91440" marT="45720" marB="45720">
+                    <a:solidFill>
+                      <a:srgbClr val="FFFFFF"/>
+                    </a:solidFill>
+                  </a:tcPr>
+                </a:tc>
+                <a:tc>
+                  <a:txBody>
+                    <a:bodyPr/>
+                    <a:lstStyle/>
+                    <a:p>
+                      <a:r>
+                        <a:rPr sz="1500" b="0">
+                          <a:solidFill>
+                            <a:srgbClr val="161616"/>
+                          </a:solidFill>
+                          <a:latin typeface="Arial"/>
+                          <a:ea typeface="Arial"/>
+                          <a:cs typeface="Arial"/>
+                        </a:rPr>
+                        <a:t>1</a:t>
+                      </a:r>
+                    </a:p>
+                  </a:txBody>
+                  <a:tcPr marL="91440" marR="91440" marT="45720" marB="45720">
+                    <a:solidFill>
+                      <a:srgbClr val="FFFFFF"/>
+                    </a:solidFill>
+                  </a:tcPr>
+                </a:tc>
+                <a:tc>
+                  <a:txBody>
+                    <a:bodyPr/>
+                    <a:lstStyle/>
+                    <a:p>
+                      <a:r>
+                        <a:rPr sz="1500" b="0">
+                          <a:solidFill>
+                            <a:srgbClr val="161616"/>
+                          </a:solidFill>
+                          <a:latin typeface="Arial"/>
+                          <a:ea typeface="Arial"/>
+                          <a:cs typeface="Arial"/>
+                        </a:rPr>
+                        <a:t>4</a:t>
+                      </a:r>
+                    </a:p>
+                  </a:txBody>
+                  <a:tcPr marL="91440" marR="91440" marT="45720" marB="45720">
+                    <a:solidFill>
+                      <a:srgbClr val="FFFFFF"/>
+                    </a:solidFill>
+                  </a:tcPr>
+                </a:tc>
+                <a:tc>
+                  <a:txBody>
+                    <a:bodyPr/>
+                    <a:lstStyle/>
+                    <a:p>
+                      <a:r>
+                        <a:rPr sz="1500" b="0">
+                          <a:solidFill>
+                            <a:srgbClr val="161616"/>
+                          </a:solidFill>
+                          <a:latin typeface="Arial"/>
+                          <a:ea typeface="Arial"/>
+                          <a:cs typeface="Arial"/>
+                        </a:rPr>
+                        <a:t>5</a:t>
+                      </a:r>
+                    </a:p>
+                  </a:txBody>
+                  <a:tcPr marL="91440" marR="91440" marT="45720" marB="45720">
+                    <a:solidFill>
+                      <a:srgbClr val="FFFFFF"/>
+                    </a:solidFill>
+                  </a:tcPr>
+                </a:tc>
+                <a:tc>
+                  <a:txBody>
+                    <a:bodyPr/>
+                    <a:lstStyle/>
+                    <a:p>
+                      <a:r>
+                        <a:rPr sz="1500" b="0">
+                          <a:solidFill>
+                            <a:srgbClr val="161616"/>
+                          </a:solidFill>
+                          <a:latin typeface="Arial"/>
+                          <a:ea typeface="Arial"/>
+                          <a:cs typeface="Arial"/>
+                        </a:rPr>
+                        <a:t>4</a:t>
+                      </a:r>
+                    </a:p>
+                  </a:txBody>
+                  <a:tcPr marL="91440" marR="91440" marT="45720" marB="45720">
+                    <a:solidFill>
+                      <a:srgbClr val="FFFFFF"/>
+                    </a:solidFill>
+                  </a:tcPr>
+                </a:tc>
+                <a:tc>
+                  <a:txBody>
+                    <a:bodyPr/>
+                    <a:lstStyle/>
+                    <a:p>
+                      <a:r>
+                        <a:rPr sz="1500" b="0">
+                          <a:solidFill>
+                            <a:srgbClr val="161616"/>
+                          </a:solidFill>
+                          <a:latin typeface="Arial"/>
+                          <a:ea typeface="Arial"/>
+                          <a:cs typeface="Arial"/>
+                        </a:rPr>
+                        <a:t>5</a:t>
+                      </a:r>
+                    </a:p>
+                  </a:txBody>
+                  <a:tcPr marL="91440" marR="91440" marT="45720" marB="45720">
+                    <a:solidFill>
+                      <a:srgbClr val="FFFFFF"/>
+                    </a:solidFill>
+                  </a:tcPr>
+                </a:tc>
+              </a:tr>
+              <a:tr h="424295">
                 <a:tc>
                   <a:txBody>
                     <a:bodyPr/>
@@ -4857,7 +5649,7 @@
     </p:spTree>
     <p:extLst>
       <p:ext uri="{BB962C8B-B14F-4D97-AF65-F5344CB8AC3E}">
-        <p14:creationId xmlns:p14="http://schemas.microsoft.com/office/powerpoint/2010/main" val="877230022"/>
+        <p14:creationId xmlns:p14="http://schemas.microsoft.com/office/powerpoint/2010/main" val="214819676"/>
       </p:ext>
     </p:extLst>
   </p:cSld>
@@ -4885,10 +5677,10 @@
       </p:grpSpPr>
       <p:sp>
         <p:nvSpPr>
-          <p:cNvPr id="3" name="">
+          <p:cNvPr id="4" name="">
             <a:extLst xmlns:a="http://schemas.openxmlformats.org/drawingml/2006/main">
               <a:ext uri="{FF2B5EF4-FFF2-40B4-BE49-F238E27FC236}">
-                <a16:creationId xmlns:a16="http://schemas.microsoft.com/office/drawing/2014/main" id="{B2B0515D-68F7-4030-A23A-4DD77A058B2B}"/>
+                <a16:creationId xmlns:a16="http://schemas.microsoft.com/office/drawing/2014/main" id="{DF332663-A9E0-4349-BB93-FCA3AC8C7EB6}"/>
               </a:ext>
             </a:extLst>
           </p:cNvPr>
@@ -4899,8 +5691,8 @@
         </p:nvSpPr>
         <p:spPr>
           <a:xfrm xmlns:a="http://schemas.openxmlformats.org/drawingml/2006/main">
-            <a:off x="552450" y="333375"/>
-            <a:ext cx="11049000" cy="857250"/>
+            <a:off x="552450" y="266700"/>
+            <a:ext cx="11049000" cy="742950"/>
           </a:xfrm>
           <a:prstGeom xmlns:a="http://schemas.openxmlformats.org/drawingml/2006/main" prst="rect">
             <a:avLst/>
@@ -4911,13 +5703,13 @@
           </a:ln>
         </p:spPr>
         <p:txBody>
-          <a:bodyPr xmlns:a="http://schemas.openxmlformats.org/drawingml/2006/main">
+          <a:bodyPr xmlns:a="http://schemas.openxmlformats.org/drawingml/2006/main" anchor="ctr">
             <a:noAutofit/>
           </a:bodyPr>
           <a:lstStyle xmlns:a="http://schemas.openxmlformats.org/drawingml/2006/main"/>
           <a:p xmlns:a="http://schemas.openxmlformats.org/drawingml/2006/main">
-            <a:pPr>
-              <a:defRPr sz="3150" b="1">
+            <a:pPr algn="l">
+              <a:defRPr sz="2700" b="1">
                 <a:solidFill>
                   <a:srgbClr val="161616"/>
                 </a:solidFill>
@@ -4927,7 +5719,7 @@
               </a:defRPr>
             </a:pPr>
             <a:r>
-              <a:rPr sz="3150" b="1">
+              <a:rPr sz="2700" b="1">
                 <a:solidFill>
                   <a:srgbClr val="161616"/>
                 </a:solidFill>
@@ -4940,32 +5732,83 @@
           </a:p>
         </p:txBody>
       </p:sp>
-      <p:pic>
-        <p:nvPicPr>
-          <p:cNvPr id="4" name=""/>
-          <p:cNvPicPr>
-            <a:picLocks xmlns:a="http://schemas.openxmlformats.org/drawingml/2006/main" noChangeAspect="1"/>
-          </p:cNvPicPr>
+      <p:graphicFrame>
+        <p:nvGraphicFramePr>
+          <p:cNvPr id="5" name="Chart"/>
+          <p:cNvGraphicFramePr/>
           <p:nvPr/>
-        </p:nvPicPr>
-        <p:blipFill>
-          <a:blip xmlns:r="http://schemas.openxmlformats.org/officeDocument/2006/relationships" xmlns:a="http://schemas.openxmlformats.org/drawingml/2006/main" r:embed="R408f0334a63943fe"/>
-          <a:stretch xmlns:a="http://schemas.openxmlformats.org/drawingml/2006/main"/>
-        </p:blipFill>
+        </p:nvGraphicFramePr>
+        <p:xfrm>
+          <a:off xmlns:a="http://schemas.openxmlformats.org/drawingml/2006/main" x="857250" y="1381125"/>
+          <a:ext xmlns:a="http://schemas.openxmlformats.org/drawingml/2006/main" cx="10477500" cy="4143375"/>
+        </p:xfrm>
+        <a:graphic xmlns:a="http://schemas.openxmlformats.org/drawingml/2006/main">
+          <a:graphicData uri="http://schemas.openxmlformats.org/drawingml/2006/chart">
+            <c:chart xmlns:r="http://schemas.openxmlformats.org/officeDocument/2006/relationships" xmlns:c="http://schemas.openxmlformats.org/drawingml/2006/chart" r:id="R8e6efddff5704885"/>
+          </a:graphicData>
+        </a:graphic>
+      </p:graphicFrame>
+      <p:sp>
+        <p:nvSpPr>
+          <p:cNvPr id="3" name="">
+            <a:extLst xmlns:a="http://schemas.openxmlformats.org/drawingml/2006/main">
+              <a:ext uri="{FF2B5EF4-FFF2-40B4-BE49-F238E27FC236}">
+                <a16:creationId xmlns:a16="http://schemas.microsoft.com/office/drawing/2014/main" id="{CD512712-9025-4A44-837A-47D78E8A0274}"/>
+              </a:ext>
+            </a:extLst>
+          </p:cNvPr>
+          <p:cNvSpPr>
+            <a:spLocks xmlns:a="http://schemas.openxmlformats.org/drawingml/2006/main" noGrp="1"/>
+          </p:cNvSpPr>
+          <p:nvPr/>
+        </p:nvSpPr>
         <p:spPr>
           <a:xfrm xmlns:a="http://schemas.openxmlformats.org/drawingml/2006/main">
-            <a:off x="2389838" y="1285875"/>
-            <a:ext cx="7412323" cy="5000625"/>
+            <a:off x="714375" y="5953125"/>
+            <a:ext cx="10668000" cy="523875"/>
           </a:xfrm>
           <a:prstGeom xmlns:a="http://schemas.openxmlformats.org/drawingml/2006/main" prst="rect">
             <a:avLst/>
           </a:prstGeom>
+          <a:noFill xmlns:a="http://schemas.openxmlformats.org/drawingml/2006/main"/>
+          <a:ln xmlns:a="http://schemas.openxmlformats.org/drawingml/2006/main" w="0">
+            <a:noFill/>
+          </a:ln>
         </p:spPr>
-      </p:pic>
+        <p:txBody>
+          <a:bodyPr xmlns:a="http://schemas.openxmlformats.org/drawingml/2006/main">
+            <a:noAutofit/>
+          </a:bodyPr>
+          <a:lstStyle xmlns:a="http://schemas.openxmlformats.org/drawingml/2006/main"/>
+          <a:p xmlns:a="http://schemas.openxmlformats.org/drawingml/2006/main">
+            <a:pPr>
+              <a:defRPr sz="1800" b="0">
+                <a:solidFill>
+                  <a:srgbClr val="161616"/>
+                </a:solidFill>
+                <a:latin typeface="Arial"/>
+                <a:ea typeface="Arial"/>
+                <a:cs typeface="Arial"/>
+              </a:defRPr>
+            </a:pPr>
+            <a:r>
+              <a:rPr sz="1800" b="0">
+                <a:solidFill>
+                  <a:srgbClr val="161616"/>
+                </a:solidFill>
+                <a:latin typeface="Arial"/>
+                <a:ea typeface="Arial"/>
+                <a:cs typeface="Arial"/>
+              </a:rPr>
+              <a:t>Девять критериев, равные веса. Оценка целевой ИС — проектная.</a:t>
+            </a:r>
+          </a:p>
+        </p:txBody>
+      </p:sp>
     </p:spTree>
     <p:extLst>
       <p:ext uri="{BB962C8B-B14F-4D97-AF65-F5344CB8AC3E}">
-        <p14:creationId xmlns:p14="http://schemas.microsoft.com/office/powerpoint/2010/main" val="1070869574"/>
+        <p14:creationId xmlns:p14="http://schemas.microsoft.com/office/powerpoint/2010/main" val="1634762286"/>
       </p:ext>
     </p:extLst>
   </p:cSld>
@@ -4996,7 +5839,7 @@
           <p:cNvPr id="7" name="">
             <a:extLst xmlns:a="http://schemas.openxmlformats.org/drawingml/2006/main">
               <a:ext uri="{FF2B5EF4-FFF2-40B4-BE49-F238E27FC236}">
-                <a16:creationId xmlns:a16="http://schemas.microsoft.com/office/drawing/2014/main" id="{CBB1F397-5E8B-43BD-A12D-74603BB353AA}"/>
+                <a16:creationId xmlns:a16="http://schemas.microsoft.com/office/drawing/2014/main" id="{141E781F-CE9B-4509-9CB9-BBCAD68E8C1C}"/>
               </a:ext>
             </a:extLst>
           </p:cNvPr>
@@ -5007,8 +5850,8 @@
         </p:nvSpPr>
         <p:spPr>
           <a:xfrm xmlns:a="http://schemas.openxmlformats.org/drawingml/2006/main">
-            <a:off x="552450" y="333375"/>
-            <a:ext cx="11049000" cy="857250"/>
+            <a:off x="552450" y="266700"/>
+            <a:ext cx="11049000" cy="742950"/>
           </a:xfrm>
           <a:prstGeom xmlns:a="http://schemas.openxmlformats.org/drawingml/2006/main" prst="rect">
             <a:avLst/>
@@ -5019,13 +5862,13 @@
           </a:ln>
         </p:spPr>
         <p:txBody>
-          <a:bodyPr xmlns:a="http://schemas.openxmlformats.org/drawingml/2006/main">
+          <a:bodyPr xmlns:a="http://schemas.openxmlformats.org/drawingml/2006/main" anchor="ctr">
             <a:noAutofit/>
           </a:bodyPr>
           <a:lstStyle xmlns:a="http://schemas.openxmlformats.org/drawingml/2006/main"/>
           <a:p xmlns:a="http://schemas.openxmlformats.org/drawingml/2006/main">
-            <a:pPr>
-              <a:defRPr sz="3150" b="1">
+            <a:pPr algn="l">
+              <a:defRPr sz="2700" b="1">
                 <a:solidFill>
                   <a:srgbClr val="161616"/>
                 </a:solidFill>
@@ -5035,7 +5878,7 @@
               </a:defRPr>
             </a:pPr>
             <a:r>
-              <a:rPr sz="3150" b="1">
+              <a:rPr sz="2700" b="1">
                 <a:solidFill>
                   <a:srgbClr val="161616"/>
                 </a:solidFill>
@@ -5053,7 +5896,7 @@
           <p:cNvPr id="2" name="">
             <a:extLst xmlns:a="http://schemas.openxmlformats.org/drawingml/2006/main">
               <a:ext uri="{FF2B5EF4-FFF2-40B4-BE49-F238E27FC236}">
-                <a16:creationId xmlns:a16="http://schemas.microsoft.com/office/drawing/2014/main" id="{E736E1BA-9AF0-4AF9-BE64-FAC96162F440}"/>
+                <a16:creationId xmlns:a16="http://schemas.microsoft.com/office/drawing/2014/main" id="{99AA62C7-EDAE-4682-B5FE-E400C2079346}"/>
               </a:ext>
             </a:extLst>
           </p:cNvPr>
@@ -5110,7 +5953,7 @@
           <p:cNvPr id="3" name="">
             <a:extLst xmlns:a="http://schemas.openxmlformats.org/drawingml/2006/main">
               <a:ext uri="{FF2B5EF4-FFF2-40B4-BE49-F238E27FC236}">
-                <a16:creationId xmlns:a16="http://schemas.microsoft.com/office/drawing/2014/main" id="{BF8DCE4B-9024-44C3-A212-C081049CBAD2}"/>
+                <a16:creationId xmlns:a16="http://schemas.microsoft.com/office/drawing/2014/main" id="{09FD1CC9-B028-49D9-A20B-B8663DE95B39}"/>
               </a:ext>
             </a:extLst>
           </p:cNvPr>
@@ -5167,7 +6010,7 @@
           <p:cNvPr id="4" name="">
             <a:extLst xmlns:a="http://schemas.openxmlformats.org/drawingml/2006/main">
               <a:ext uri="{FF2B5EF4-FFF2-40B4-BE49-F238E27FC236}">
-                <a16:creationId xmlns:a16="http://schemas.microsoft.com/office/drawing/2014/main" id="{D38A424F-D8B8-478C-8620-562F2537C92D}"/>
+                <a16:creationId xmlns:a16="http://schemas.microsoft.com/office/drawing/2014/main" id="{F4387C25-17E8-4097-81F7-802ED91F56E1}"/>
               </a:ext>
             </a:extLst>
           </p:cNvPr>
@@ -5224,7 +6067,7 @@
           <p:cNvPr id="5" name="">
             <a:extLst xmlns:a="http://schemas.openxmlformats.org/drawingml/2006/main">
               <a:ext uri="{FF2B5EF4-FFF2-40B4-BE49-F238E27FC236}">
-                <a16:creationId xmlns:a16="http://schemas.microsoft.com/office/drawing/2014/main" id="{3C7176B1-B355-4B7F-863A-5E61FB6BE632}"/>
+                <a16:creationId xmlns:a16="http://schemas.microsoft.com/office/drawing/2014/main" id="{B7D318EE-1FF2-4DDC-BCB7-E2C00567498C}"/>
               </a:ext>
             </a:extLst>
           </p:cNvPr>
@@ -5281,7 +6124,7 @@
           <p:cNvPr id="6" name="">
             <a:extLst xmlns:a="http://schemas.openxmlformats.org/drawingml/2006/main">
               <a:ext uri="{FF2B5EF4-FFF2-40B4-BE49-F238E27FC236}">
-                <a16:creationId xmlns:a16="http://schemas.microsoft.com/office/drawing/2014/main" id="{4252E59A-3981-4F4D-9D20-0569442CC2BC}"/>
+                <a16:creationId xmlns:a16="http://schemas.microsoft.com/office/drawing/2014/main" id="{3DDC777A-2954-4807-BC1A-E82CF69A576B}"/>
               </a:ext>
             </a:extLst>
           </p:cNvPr>
@@ -5336,7 +6179,7 @@
     </p:spTree>
     <p:extLst>
       <p:ext uri="{BB962C8B-B14F-4D97-AF65-F5344CB8AC3E}">
-        <p14:creationId xmlns:p14="http://schemas.microsoft.com/office/powerpoint/2010/main" val="619859806"/>
+        <p14:creationId xmlns:p14="http://schemas.microsoft.com/office/powerpoint/2010/main" val="946619051"/>
       </p:ext>
     </p:extLst>
   </p:cSld>
@@ -5367,7 +6210,7 @@
           <p:cNvPr id="6" name="">
             <a:extLst xmlns:a="http://schemas.openxmlformats.org/drawingml/2006/main">
               <a:ext uri="{FF2B5EF4-FFF2-40B4-BE49-F238E27FC236}">
-                <a16:creationId xmlns:a16="http://schemas.microsoft.com/office/drawing/2014/main" id="{BEB13798-1CBE-43BC-889D-01A5A021BE94}"/>
+                <a16:creationId xmlns:a16="http://schemas.microsoft.com/office/drawing/2014/main" id="{E4AC517C-AD80-4CE6-8331-4FE044CD8775}"/>
               </a:ext>
             </a:extLst>
           </p:cNvPr>
@@ -5378,8 +6221,8 @@
         </p:nvSpPr>
         <p:spPr>
           <a:xfrm xmlns:a="http://schemas.openxmlformats.org/drawingml/2006/main">
-            <a:off x="552450" y="333375"/>
-            <a:ext cx="11049000" cy="857250"/>
+            <a:off x="552450" y="266700"/>
+            <a:ext cx="11049000" cy="742950"/>
           </a:xfrm>
           <a:prstGeom xmlns:a="http://schemas.openxmlformats.org/drawingml/2006/main" prst="rect">
             <a:avLst/>
@@ -5390,13 +6233,13 @@
           </a:ln>
         </p:spPr>
         <p:txBody>
-          <a:bodyPr xmlns:a="http://schemas.openxmlformats.org/drawingml/2006/main">
+          <a:bodyPr xmlns:a="http://schemas.openxmlformats.org/drawingml/2006/main" anchor="ctr">
             <a:noAutofit/>
           </a:bodyPr>
           <a:lstStyle xmlns:a="http://schemas.openxmlformats.org/drawingml/2006/main"/>
           <a:p xmlns:a="http://schemas.openxmlformats.org/drawingml/2006/main">
-            <a:pPr>
-              <a:defRPr sz="3150" b="1">
+            <a:pPr algn="l">
+              <a:defRPr sz="2700" b="1">
                 <a:solidFill>
                   <a:srgbClr val="161616"/>
                 </a:solidFill>
@@ -5406,7 +6249,7 @@
               </a:defRPr>
             </a:pPr>
             <a:r>
-              <a:rPr sz="3150" b="1">
+              <a:rPr sz="2700" b="1">
                 <a:solidFill>
                   <a:srgbClr val="161616"/>
                 </a:solidFill>
@@ -5424,7 +6267,7 @@
           <p:cNvPr id="2" name="">
             <a:extLst xmlns:a="http://schemas.openxmlformats.org/drawingml/2006/main">
               <a:ext uri="{FF2B5EF4-FFF2-40B4-BE49-F238E27FC236}">
-                <a16:creationId xmlns:a16="http://schemas.microsoft.com/office/drawing/2014/main" id="{43AD8FE4-0A39-4BB3-BEC3-B2A9D319DEB5}"/>
+                <a16:creationId xmlns:a16="http://schemas.microsoft.com/office/drawing/2014/main" id="{79E0B401-972B-4BAF-81BB-132ED94C6757}"/>
               </a:ext>
             </a:extLst>
           </p:cNvPr>
@@ -5481,7 +6324,7 @@
           <p:cNvPr id="3" name="">
             <a:extLst xmlns:a="http://schemas.openxmlformats.org/drawingml/2006/main">
               <a:ext uri="{FF2B5EF4-FFF2-40B4-BE49-F238E27FC236}">
-                <a16:creationId xmlns:a16="http://schemas.microsoft.com/office/drawing/2014/main" id="{3EEB8BFE-ADEF-406B-A863-1D1364FC439A}"/>
+                <a16:creationId xmlns:a16="http://schemas.microsoft.com/office/drawing/2014/main" id="{FEA95B91-C6E3-4A40-9D9C-748F7F775A55}"/>
               </a:ext>
             </a:extLst>
           </p:cNvPr>
@@ -5538,7 +6381,7 @@
           <p:cNvPr id="4" name="">
             <a:extLst xmlns:a="http://schemas.openxmlformats.org/drawingml/2006/main">
               <a:ext uri="{FF2B5EF4-FFF2-40B4-BE49-F238E27FC236}">
-                <a16:creationId xmlns:a16="http://schemas.microsoft.com/office/drawing/2014/main" id="{0B248AC8-185B-4483-85D8-498E36829399}"/>
+                <a16:creationId xmlns:a16="http://schemas.microsoft.com/office/drawing/2014/main" id="{76781859-EA9C-4E8F-B3B2-C51DC3B990FC}"/>
               </a:ext>
             </a:extLst>
           </p:cNvPr>
@@ -5595,7 +6438,7 @@
           <p:cNvPr id="5" name="">
             <a:extLst xmlns:a="http://schemas.openxmlformats.org/drawingml/2006/main">
               <a:ext uri="{FF2B5EF4-FFF2-40B4-BE49-F238E27FC236}">
-                <a16:creationId xmlns:a16="http://schemas.microsoft.com/office/drawing/2014/main" id="{F6133721-981A-4D56-8B51-6C10B483387A}"/>
+                <a16:creationId xmlns:a16="http://schemas.microsoft.com/office/drawing/2014/main" id="{4B22E37B-C658-41A8-8182-228ACCBE6909}"/>
               </a:ext>
             </a:extLst>
           </p:cNvPr>
@@ -5650,7 +6493,7 @@
     </p:spTree>
     <p:extLst>
       <p:ext uri="{BB962C8B-B14F-4D97-AF65-F5344CB8AC3E}">
-        <p14:creationId xmlns:p14="http://schemas.microsoft.com/office/powerpoint/2010/main" val="1957573086"/>
+        <p14:creationId xmlns:p14="http://schemas.microsoft.com/office/powerpoint/2010/main" val="1047273422"/>
       </p:ext>
     </p:extLst>
   </p:cSld>
@@ -5681,7 +6524,7 @@
           <p:cNvPr id="10" name="">
             <a:extLst xmlns:a="http://schemas.openxmlformats.org/drawingml/2006/main">
               <a:ext uri="{FF2B5EF4-FFF2-40B4-BE49-F238E27FC236}">
-                <a16:creationId xmlns:a16="http://schemas.microsoft.com/office/drawing/2014/main" id="{25E4431A-B8C8-4EF5-94AA-3BE6B57A011B}"/>
+                <a16:creationId xmlns:a16="http://schemas.microsoft.com/office/drawing/2014/main" id="{8A069FBD-B423-40EE-AB85-273219646E05}"/>
               </a:ext>
             </a:extLst>
           </p:cNvPr>
@@ -5692,8 +6535,8 @@
         </p:nvSpPr>
         <p:spPr>
           <a:xfrm xmlns:a="http://schemas.openxmlformats.org/drawingml/2006/main">
-            <a:off x="552450" y="333375"/>
-            <a:ext cx="11049000" cy="857250"/>
+            <a:off x="552450" y="266700"/>
+            <a:ext cx="11049000" cy="742950"/>
           </a:xfrm>
           <a:prstGeom xmlns:a="http://schemas.openxmlformats.org/drawingml/2006/main" prst="rect">
             <a:avLst/>
@@ -5704,13 +6547,13 @@
           </a:ln>
         </p:spPr>
         <p:txBody>
-          <a:bodyPr xmlns:a="http://schemas.openxmlformats.org/drawingml/2006/main">
+          <a:bodyPr xmlns:a="http://schemas.openxmlformats.org/drawingml/2006/main" anchor="ctr">
             <a:noAutofit/>
           </a:bodyPr>
           <a:lstStyle xmlns:a="http://schemas.openxmlformats.org/drawingml/2006/main"/>
           <a:p xmlns:a="http://schemas.openxmlformats.org/drawingml/2006/main">
-            <a:pPr>
-              <a:defRPr sz="3150" b="1">
+            <a:pPr algn="l">
+              <a:defRPr sz="2700" b="1">
                 <a:solidFill>
                   <a:srgbClr val="161616"/>
                 </a:solidFill>
@@ -5720,7 +6563,7 @@
               </a:defRPr>
             </a:pPr>
             <a:r>
-              <a:rPr sz="3150" b="1">
+              <a:rPr sz="2700" b="1">
                 <a:solidFill>
                   <a:srgbClr val="161616"/>
                 </a:solidFill>
@@ -5738,7 +6581,7 @@
           <p:cNvPr id="2" name="">
             <a:extLst xmlns:a="http://schemas.openxmlformats.org/drawingml/2006/main">
               <a:ext uri="{FF2B5EF4-FFF2-40B4-BE49-F238E27FC236}">
-                <a16:creationId xmlns:a16="http://schemas.microsoft.com/office/drawing/2014/main" id="{D4D00783-EAF0-4DC3-A898-FA6EEE14E880}"/>
+                <a16:creationId xmlns:a16="http://schemas.microsoft.com/office/drawing/2014/main" id="{075FFE89-8D10-42B6-860E-5B3D8AC505A1}"/>
               </a:ext>
             </a:extLst>
           </p:cNvPr>
@@ -5795,7 +6638,7 @@
           <p:cNvPr id="3" name="">
             <a:extLst xmlns:a="http://schemas.openxmlformats.org/drawingml/2006/main">
               <a:ext uri="{FF2B5EF4-FFF2-40B4-BE49-F238E27FC236}">
-                <a16:creationId xmlns:a16="http://schemas.microsoft.com/office/drawing/2014/main" id="{72C8F770-54CF-4290-B804-5847C48F7493}"/>
+                <a16:creationId xmlns:a16="http://schemas.microsoft.com/office/drawing/2014/main" id="{DA73AB3D-0AD2-4845-AADE-2EA163A1FB21}"/>
               </a:ext>
             </a:extLst>
           </p:cNvPr>
@@ -5852,7 +6695,7 @@
           <p:cNvPr id="4" name="">
             <a:extLst xmlns:a="http://schemas.openxmlformats.org/drawingml/2006/main">
               <a:ext uri="{FF2B5EF4-FFF2-40B4-BE49-F238E27FC236}">
-                <a16:creationId xmlns:a16="http://schemas.microsoft.com/office/drawing/2014/main" id="{775A9206-3641-4285-A628-3FD392F81CDB}"/>
+                <a16:creationId xmlns:a16="http://schemas.microsoft.com/office/drawing/2014/main" id="{9107FFF2-9017-4086-89EA-640DFBC72C0E}"/>
               </a:ext>
             </a:extLst>
           </p:cNvPr>
@@ -5909,7 +6752,7 @@
           <p:cNvPr id="5" name="">
             <a:extLst xmlns:a="http://schemas.openxmlformats.org/drawingml/2006/main">
               <a:ext uri="{FF2B5EF4-FFF2-40B4-BE49-F238E27FC236}">
-                <a16:creationId xmlns:a16="http://schemas.microsoft.com/office/drawing/2014/main" id="{5BFD0907-347A-4A99-90FD-364588788A75}"/>
+                <a16:creationId xmlns:a16="http://schemas.microsoft.com/office/drawing/2014/main" id="{F153AD95-F97B-41DD-B49B-9F769BAE9778}"/>
               </a:ext>
             </a:extLst>
           </p:cNvPr>
@@ -5966,7 +6809,7 @@
           <p:cNvPr id="6" name="">
             <a:extLst xmlns:a="http://schemas.openxmlformats.org/drawingml/2006/main">
               <a:ext uri="{FF2B5EF4-FFF2-40B4-BE49-F238E27FC236}">
-                <a16:creationId xmlns:a16="http://schemas.microsoft.com/office/drawing/2014/main" id="{CE06F7AD-6010-430E-A803-8937D33D6F7C}"/>
+                <a16:creationId xmlns:a16="http://schemas.microsoft.com/office/drawing/2014/main" id="{C1DB70F5-CC1D-4F07-980A-27EF904CFBF9}"/>
               </a:ext>
             </a:extLst>
           </p:cNvPr>
@@ -6023,7 +6866,7 @@
           <p:cNvPr id="7" name="">
             <a:extLst xmlns:a="http://schemas.openxmlformats.org/drawingml/2006/main">
               <a:ext uri="{FF2B5EF4-FFF2-40B4-BE49-F238E27FC236}">
-                <a16:creationId xmlns:a16="http://schemas.microsoft.com/office/drawing/2014/main" id="{A9D02905-965B-4883-8AC9-3F7BE02A803E}"/>
+                <a16:creationId xmlns:a16="http://schemas.microsoft.com/office/drawing/2014/main" id="{5261F5EA-9F62-4A18-BC56-346F78DCB8F5}"/>
               </a:ext>
             </a:extLst>
           </p:cNvPr>
@@ -6080,7 +6923,7 @@
           <p:cNvPr id="8" name="">
             <a:extLst xmlns:a="http://schemas.openxmlformats.org/drawingml/2006/main">
               <a:ext uri="{FF2B5EF4-FFF2-40B4-BE49-F238E27FC236}">
-                <a16:creationId xmlns:a16="http://schemas.microsoft.com/office/drawing/2014/main" id="{E9A43341-03D1-43AE-8FDC-87FA9CA98F54}"/>
+                <a16:creationId xmlns:a16="http://schemas.microsoft.com/office/drawing/2014/main" id="{369543DE-56FF-44A9-9230-C72CE6B893A6}"/>
               </a:ext>
             </a:extLst>
           </p:cNvPr>
@@ -6137,7 +6980,7 @@
           <p:cNvPr id="9" name="">
             <a:extLst xmlns:a="http://schemas.openxmlformats.org/drawingml/2006/main">
               <a:ext uri="{FF2B5EF4-FFF2-40B4-BE49-F238E27FC236}">
-                <a16:creationId xmlns:a16="http://schemas.microsoft.com/office/drawing/2014/main" id="{C2938C2F-6D92-4A33-956D-31A59467F0F1}"/>
+                <a16:creationId xmlns:a16="http://schemas.microsoft.com/office/drawing/2014/main" id="{6365D2E1-AF6C-467A-8929-65080C7B1260}"/>
               </a:ext>
             </a:extLst>
           </p:cNvPr>
@@ -6192,7 +7035,7 @@
     </p:spTree>
     <p:extLst>
       <p:ext uri="{BB962C8B-B14F-4D97-AF65-F5344CB8AC3E}">
-        <p14:creationId xmlns:p14="http://schemas.microsoft.com/office/powerpoint/2010/main" val="1306794225"/>
+        <p14:creationId xmlns:p14="http://schemas.microsoft.com/office/powerpoint/2010/main" val="944080899"/>
       </p:ext>
     </p:extLst>
   </p:cSld>
@@ -6223,7 +7066,7 @@
           <p:cNvPr id="3" name="">
             <a:extLst xmlns:a="http://schemas.openxmlformats.org/drawingml/2006/main">
               <a:ext uri="{FF2B5EF4-FFF2-40B4-BE49-F238E27FC236}">
-                <a16:creationId xmlns:a16="http://schemas.microsoft.com/office/drawing/2014/main" id="{8B6366BA-0E80-44A6-8C7D-821BE71B03E3}"/>
+                <a16:creationId xmlns:a16="http://schemas.microsoft.com/office/drawing/2014/main" id="{E6B216F1-5E87-4E57-88FD-7A066771591C}"/>
               </a:ext>
             </a:extLst>
           </p:cNvPr>
@@ -6234,8 +7077,8 @@
         </p:nvSpPr>
         <p:spPr>
           <a:xfrm xmlns:a="http://schemas.openxmlformats.org/drawingml/2006/main">
-            <a:off x="552450" y="333375"/>
-            <a:ext cx="11049000" cy="857250"/>
+            <a:off x="552450" y="266700"/>
+            <a:ext cx="11049000" cy="742950"/>
           </a:xfrm>
           <a:prstGeom xmlns:a="http://schemas.openxmlformats.org/drawingml/2006/main" prst="rect">
             <a:avLst/>
@@ -6246,13 +7089,13 @@
           </a:ln>
         </p:spPr>
         <p:txBody>
-          <a:bodyPr xmlns:a="http://schemas.openxmlformats.org/drawingml/2006/main">
+          <a:bodyPr xmlns:a="http://schemas.openxmlformats.org/drawingml/2006/main" anchor="ctr">
             <a:noAutofit/>
           </a:bodyPr>
           <a:lstStyle xmlns:a="http://schemas.openxmlformats.org/drawingml/2006/main"/>
           <a:p xmlns:a="http://schemas.openxmlformats.org/drawingml/2006/main">
-            <a:pPr>
-              <a:defRPr sz="3150" b="1">
+            <a:pPr algn="l">
+              <a:defRPr sz="2700" b="1">
                 <a:solidFill>
                   <a:srgbClr val="161616"/>
                 </a:solidFill>
@@ -6262,7 +7105,7 @@
               </a:defRPr>
             </a:pPr>
             <a:r>
-              <a:rPr sz="3150" b="1">
+              <a:rPr sz="2700" b="1">
                 <a:solidFill>
                   <a:srgbClr val="161616"/>
                 </a:solidFill>
@@ -6284,13 +7127,13 @@
           <p:nvPr/>
         </p:nvPicPr>
         <p:blipFill>
-          <a:blip xmlns:r="http://schemas.openxmlformats.org/officeDocument/2006/relationships" xmlns:a="http://schemas.openxmlformats.org/drawingml/2006/main" r:embed="R3ec2ab283d234a6e"/>
+          <a:blip xmlns:r="http://schemas.openxmlformats.org/officeDocument/2006/relationships" xmlns:a="http://schemas.openxmlformats.org/drawingml/2006/main" r:embed="R07fdda7124ab4fea"/>
           <a:stretch xmlns:a="http://schemas.openxmlformats.org/drawingml/2006/main"/>
         </p:blipFill>
         <p:spPr>
           <a:xfrm xmlns:a="http://schemas.openxmlformats.org/drawingml/2006/main">
-            <a:off x="1791338" y="1285875"/>
-            <a:ext cx="8609323" cy="5000625"/>
+            <a:off x="1895475" y="1285875"/>
+            <a:ext cx="8401050" cy="5000625"/>
           </a:xfrm>
           <a:prstGeom xmlns:a="http://schemas.openxmlformats.org/drawingml/2006/main" prst="rect">
             <a:avLst/>
@@ -6300,7 +7143,7 @@
     </p:spTree>
     <p:extLst>
       <p:ext uri="{BB962C8B-B14F-4D97-AF65-F5344CB8AC3E}">
-        <p14:creationId xmlns:p14="http://schemas.microsoft.com/office/powerpoint/2010/main" val="844860473"/>
+        <p14:creationId xmlns:p14="http://schemas.microsoft.com/office/powerpoint/2010/main" val="1240881008"/>
       </p:ext>
     </p:extLst>
   </p:cSld>
@@ -6331,7 +7174,7 @@
           <p:cNvPr id="3" name="">
             <a:extLst xmlns:a="http://schemas.openxmlformats.org/drawingml/2006/main">
               <a:ext uri="{FF2B5EF4-FFF2-40B4-BE49-F238E27FC236}">
-                <a16:creationId xmlns:a16="http://schemas.microsoft.com/office/drawing/2014/main" id="{8D99CED6-C746-4B0B-B2C4-1ECA71A39C23}"/>
+                <a16:creationId xmlns:a16="http://schemas.microsoft.com/office/drawing/2014/main" id="{219612A8-E70D-45D9-9F43-E8C79FC8EC9A}"/>
               </a:ext>
             </a:extLst>
           </p:cNvPr>
@@ -6342,8 +7185,8 @@
         </p:nvSpPr>
         <p:spPr>
           <a:xfrm xmlns:a="http://schemas.openxmlformats.org/drawingml/2006/main">
-            <a:off x="552450" y="333375"/>
-            <a:ext cx="11049000" cy="857250"/>
+            <a:off x="552450" y="266700"/>
+            <a:ext cx="11049000" cy="742950"/>
           </a:xfrm>
           <a:prstGeom xmlns:a="http://schemas.openxmlformats.org/drawingml/2006/main" prst="rect">
             <a:avLst/>
@@ -6354,13 +7197,13 @@
           </a:ln>
         </p:spPr>
         <p:txBody>
-          <a:bodyPr xmlns:a="http://schemas.openxmlformats.org/drawingml/2006/main">
+          <a:bodyPr xmlns:a="http://schemas.openxmlformats.org/drawingml/2006/main" anchor="ctr">
             <a:noAutofit/>
           </a:bodyPr>
           <a:lstStyle xmlns:a="http://schemas.openxmlformats.org/drawingml/2006/main"/>
           <a:p xmlns:a="http://schemas.openxmlformats.org/drawingml/2006/main">
-            <a:pPr>
-              <a:defRPr sz="3150" b="1">
+            <a:pPr algn="l">
+              <a:defRPr sz="2700" b="1">
                 <a:solidFill>
                   <a:srgbClr val="161616"/>
                 </a:solidFill>
@@ -6370,7 +7213,7 @@
               </a:defRPr>
             </a:pPr>
             <a:r>
-              <a:rPr sz="3150" b="1">
+              <a:rPr sz="2700" b="1">
                 <a:solidFill>
                   <a:srgbClr val="161616"/>
                 </a:solidFill>
@@ -6392,13 +7235,13 @@
           <p:nvPr/>
         </p:nvPicPr>
         <p:blipFill>
-          <a:blip xmlns:r="http://schemas.openxmlformats.org/officeDocument/2006/relationships" xmlns:a="http://schemas.openxmlformats.org/drawingml/2006/main" r:embed="Rafcd52813a37445c"/>
+          <a:blip xmlns:r="http://schemas.openxmlformats.org/officeDocument/2006/relationships" xmlns:a="http://schemas.openxmlformats.org/drawingml/2006/main" r:embed="R588250dd0edb48cf"/>
           <a:stretch xmlns:a="http://schemas.openxmlformats.org/drawingml/2006/main"/>
         </p:blipFill>
         <p:spPr>
           <a:xfrm xmlns:a="http://schemas.openxmlformats.org/drawingml/2006/main">
-            <a:off x="2070381" y="1285875"/>
-            <a:ext cx="8051239" cy="5000625"/>
+            <a:off x="1895475" y="1285875"/>
+            <a:ext cx="8401050" cy="5000625"/>
           </a:xfrm>
           <a:prstGeom xmlns:a="http://schemas.openxmlformats.org/drawingml/2006/main" prst="rect">
             <a:avLst/>
@@ -6408,7 +7251,7 @@
     </p:spTree>
     <p:extLst>
       <p:ext uri="{BB962C8B-B14F-4D97-AF65-F5344CB8AC3E}">
-        <p14:creationId xmlns:p14="http://schemas.microsoft.com/office/powerpoint/2010/main" val="573663930"/>
+        <p14:creationId xmlns:p14="http://schemas.microsoft.com/office/powerpoint/2010/main" val="788901821"/>
       </p:ext>
     </p:extLst>
   </p:cSld>
@@ -6439,7 +7282,7 @@
           <p:cNvPr id="3" name="">
             <a:extLst xmlns:a="http://schemas.openxmlformats.org/drawingml/2006/main">
               <a:ext uri="{FF2B5EF4-FFF2-40B4-BE49-F238E27FC236}">
-                <a16:creationId xmlns:a16="http://schemas.microsoft.com/office/drawing/2014/main" id="{7884C126-3CAE-4DCA-BDEA-F08D9F0F2ED9}"/>
+                <a16:creationId xmlns:a16="http://schemas.microsoft.com/office/drawing/2014/main" id="{23A4B3A8-D9FB-49F9-B9F0-5131825C22F0}"/>
               </a:ext>
             </a:extLst>
           </p:cNvPr>
@@ -6450,8 +7293,8 @@
         </p:nvSpPr>
         <p:spPr>
           <a:xfrm xmlns:a="http://schemas.openxmlformats.org/drawingml/2006/main">
-            <a:off x="552450" y="333375"/>
-            <a:ext cx="11049000" cy="857250"/>
+            <a:off x="552450" y="266700"/>
+            <a:ext cx="11049000" cy="742950"/>
           </a:xfrm>
           <a:prstGeom xmlns:a="http://schemas.openxmlformats.org/drawingml/2006/main" prst="rect">
             <a:avLst/>
@@ -6462,13 +7305,13 @@
           </a:ln>
         </p:spPr>
         <p:txBody>
-          <a:bodyPr xmlns:a="http://schemas.openxmlformats.org/drawingml/2006/main">
+          <a:bodyPr xmlns:a="http://schemas.openxmlformats.org/drawingml/2006/main" anchor="ctr">
             <a:noAutofit/>
           </a:bodyPr>
           <a:lstStyle xmlns:a="http://schemas.openxmlformats.org/drawingml/2006/main"/>
           <a:p xmlns:a="http://schemas.openxmlformats.org/drawingml/2006/main">
-            <a:pPr>
-              <a:defRPr sz="3150" b="1">
+            <a:pPr algn="l">
+              <a:defRPr sz="2700" b="1">
                 <a:solidFill>
                   <a:srgbClr val="161616"/>
                 </a:solidFill>
@@ -6478,7 +7321,7 @@
               </a:defRPr>
             </a:pPr>
             <a:r>
-              <a:rPr sz="3150" b="1">
+              <a:rPr sz="2700" b="1">
                 <a:solidFill>
                   <a:srgbClr val="161616"/>
                 </a:solidFill>
@@ -6500,13 +7343,13 @@
           <p:nvPr/>
         </p:nvPicPr>
         <p:blipFill>
-          <a:blip xmlns:r="http://schemas.openxmlformats.org/officeDocument/2006/relationships" xmlns:a="http://schemas.openxmlformats.org/drawingml/2006/main" r:embed="Rd3e7f02b22bf47ef"/>
+          <a:blip xmlns:r="http://schemas.openxmlformats.org/officeDocument/2006/relationships" xmlns:a="http://schemas.openxmlformats.org/drawingml/2006/main" r:embed="R0813594d7c194a54"/>
           <a:stretch xmlns:a="http://schemas.openxmlformats.org/drawingml/2006/main"/>
         </p:blipFill>
         <p:spPr>
           <a:xfrm xmlns:a="http://schemas.openxmlformats.org/drawingml/2006/main">
-            <a:off x="571500" y="1500921"/>
-            <a:ext cx="11049000" cy="4570534"/>
+            <a:off x="571500" y="1581649"/>
+            <a:ext cx="11049000" cy="4409077"/>
           </a:xfrm>
           <a:prstGeom xmlns:a="http://schemas.openxmlformats.org/drawingml/2006/main" prst="rect">
             <a:avLst/>
@@ -6516,7 +7359,7 @@
     </p:spTree>
     <p:extLst>
       <p:ext uri="{BB962C8B-B14F-4D97-AF65-F5344CB8AC3E}">
-        <p14:creationId xmlns:p14="http://schemas.microsoft.com/office/powerpoint/2010/main" val="1397974917"/>
+        <p14:creationId xmlns:p14="http://schemas.microsoft.com/office/powerpoint/2010/main" val="2024295739"/>
       </p:ext>
     </p:extLst>
   </p:cSld>
@@ -6547,7 +7390,7 @@
           <p:cNvPr id="3" name="">
             <a:extLst xmlns:a="http://schemas.openxmlformats.org/drawingml/2006/main">
               <a:ext uri="{FF2B5EF4-FFF2-40B4-BE49-F238E27FC236}">
-                <a16:creationId xmlns:a16="http://schemas.microsoft.com/office/drawing/2014/main" id="{F773B031-0916-4AC4-A1AD-16EA5E5C5FA8}"/>
+                <a16:creationId xmlns:a16="http://schemas.microsoft.com/office/drawing/2014/main" id="{48AAE040-571F-460C-8A24-0B4C4E0EFA46}"/>
               </a:ext>
             </a:extLst>
           </p:cNvPr>
@@ -6558,8 +7401,8 @@
         </p:nvSpPr>
         <p:spPr>
           <a:xfrm xmlns:a="http://schemas.openxmlformats.org/drawingml/2006/main">
-            <a:off x="552450" y="333375"/>
-            <a:ext cx="11049000" cy="857250"/>
+            <a:off x="552450" y="266700"/>
+            <a:ext cx="11049000" cy="742950"/>
           </a:xfrm>
           <a:prstGeom xmlns:a="http://schemas.openxmlformats.org/drawingml/2006/main" prst="rect">
             <a:avLst/>
@@ -6570,13 +7413,13 @@
           </a:ln>
         </p:spPr>
         <p:txBody>
-          <a:bodyPr xmlns:a="http://schemas.openxmlformats.org/drawingml/2006/main">
+          <a:bodyPr xmlns:a="http://schemas.openxmlformats.org/drawingml/2006/main" anchor="ctr">
             <a:noAutofit/>
           </a:bodyPr>
           <a:lstStyle xmlns:a="http://schemas.openxmlformats.org/drawingml/2006/main"/>
           <a:p xmlns:a="http://schemas.openxmlformats.org/drawingml/2006/main">
-            <a:pPr>
-              <a:defRPr sz="3150" b="1">
+            <a:pPr algn="l">
+              <a:defRPr sz="2700" b="1">
                 <a:solidFill>
                   <a:srgbClr val="161616"/>
                 </a:solidFill>
@@ -6586,7 +7429,7 @@
               </a:defRPr>
             </a:pPr>
             <a:r>
-              <a:rPr sz="3150" b="1">
+              <a:rPr sz="2700" b="1">
                 <a:solidFill>
                   <a:srgbClr val="161616"/>
                 </a:solidFill>
@@ -6608,13 +7451,13 @@
           <p:nvPr/>
         </p:nvPicPr>
         <p:blipFill>
-          <a:blip xmlns:r="http://schemas.openxmlformats.org/officeDocument/2006/relationships" xmlns:a="http://schemas.openxmlformats.org/drawingml/2006/main" r:embed="R9837e59922684089"/>
+          <a:blip xmlns:r="http://schemas.openxmlformats.org/officeDocument/2006/relationships" xmlns:a="http://schemas.openxmlformats.org/drawingml/2006/main" r:embed="Rcf4651a04c3943bc"/>
           <a:stretch xmlns:a="http://schemas.openxmlformats.org/drawingml/2006/main"/>
         </p:blipFill>
         <p:spPr>
           <a:xfrm xmlns:a="http://schemas.openxmlformats.org/drawingml/2006/main">
-            <a:off x="703917" y="1285875"/>
-            <a:ext cx="10784165" cy="5000625"/>
+            <a:off x="571500" y="1326470"/>
+            <a:ext cx="11049000" cy="4919436"/>
           </a:xfrm>
           <a:prstGeom xmlns:a="http://schemas.openxmlformats.org/drawingml/2006/main" prst="rect">
             <a:avLst/>
@@ -6624,7 +7467,7 @@
     </p:spTree>
     <p:extLst>
       <p:ext uri="{BB962C8B-B14F-4D97-AF65-F5344CB8AC3E}">
-        <p14:creationId xmlns:p14="http://schemas.microsoft.com/office/powerpoint/2010/main" val="502290392"/>
+        <p14:creationId xmlns:p14="http://schemas.microsoft.com/office/powerpoint/2010/main" val="1120295978"/>
       </p:ext>
     </p:extLst>
   </p:cSld>
@@ -6655,7 +7498,7 @@
           <p:cNvPr id="3" name="">
             <a:extLst xmlns:a="http://schemas.openxmlformats.org/drawingml/2006/main">
               <a:ext uri="{FF2B5EF4-FFF2-40B4-BE49-F238E27FC236}">
-                <a16:creationId xmlns:a16="http://schemas.microsoft.com/office/drawing/2014/main" id="{9B4572E3-D1CD-4E12-B334-D53792EB2BA1}"/>
+                <a16:creationId xmlns:a16="http://schemas.microsoft.com/office/drawing/2014/main" id="{914EFF33-DCF8-4B00-9E71-99741E48E097}"/>
               </a:ext>
             </a:extLst>
           </p:cNvPr>
@@ -6666,8 +7509,8 @@
         </p:nvSpPr>
         <p:spPr>
           <a:xfrm xmlns:a="http://schemas.openxmlformats.org/drawingml/2006/main">
-            <a:off x="552450" y="333375"/>
-            <a:ext cx="11049000" cy="857250"/>
+            <a:off x="552450" y="266700"/>
+            <a:ext cx="11049000" cy="742950"/>
           </a:xfrm>
           <a:prstGeom xmlns:a="http://schemas.openxmlformats.org/drawingml/2006/main" prst="rect">
             <a:avLst/>
@@ -6678,13 +7521,13 @@
           </a:ln>
         </p:spPr>
         <p:txBody>
-          <a:bodyPr xmlns:a="http://schemas.openxmlformats.org/drawingml/2006/main">
+          <a:bodyPr xmlns:a="http://schemas.openxmlformats.org/drawingml/2006/main" anchor="ctr">
             <a:noAutofit/>
           </a:bodyPr>
           <a:lstStyle xmlns:a="http://schemas.openxmlformats.org/drawingml/2006/main"/>
           <a:p xmlns:a="http://schemas.openxmlformats.org/drawingml/2006/main">
-            <a:pPr>
-              <a:defRPr sz="3150" b="1">
+            <a:pPr algn="l">
+              <a:defRPr sz="2700" b="1">
                 <a:solidFill>
                   <a:srgbClr val="161616"/>
                 </a:solidFill>
@@ -6694,7 +7537,7 @@
               </a:defRPr>
             </a:pPr>
             <a:r>
-              <a:rPr sz="3150" b="1">
+              <a:rPr sz="2700" b="1">
                 <a:solidFill>
                   <a:srgbClr val="161616"/>
                 </a:solidFill>
@@ -7251,7 +8094,7 @@
     </p:spTree>
     <p:extLst>
       <p:ext uri="{BB962C8B-B14F-4D97-AF65-F5344CB8AC3E}">
-        <p14:creationId xmlns:p14="http://schemas.microsoft.com/office/powerpoint/2010/main" val="1047885025"/>
+        <p14:creationId xmlns:p14="http://schemas.microsoft.com/office/powerpoint/2010/main" val="709318687"/>
       </p:ext>
     </p:extLst>
   </p:cSld>
@@ -7282,7 +8125,7 @@
           <p:cNvPr id="14" name="">
             <a:extLst xmlns:a="http://schemas.openxmlformats.org/drawingml/2006/main">
               <a:ext uri="{FF2B5EF4-FFF2-40B4-BE49-F238E27FC236}">
-                <a16:creationId xmlns:a16="http://schemas.microsoft.com/office/drawing/2014/main" id="{9C29AD7D-836B-4EED-B2DE-41D6FFDC71B1}"/>
+                <a16:creationId xmlns:a16="http://schemas.microsoft.com/office/drawing/2014/main" id="{0E38AD2A-43A8-46C4-8FA8-EFBB271EFC42}"/>
               </a:ext>
             </a:extLst>
           </p:cNvPr>
@@ -7293,8 +8136,8 @@
         </p:nvSpPr>
         <p:spPr>
           <a:xfrm xmlns:a="http://schemas.openxmlformats.org/drawingml/2006/main">
-            <a:off x="552450" y="333375"/>
-            <a:ext cx="11049000" cy="857250"/>
+            <a:off x="552450" y="266700"/>
+            <a:ext cx="11049000" cy="742950"/>
           </a:xfrm>
           <a:prstGeom xmlns:a="http://schemas.openxmlformats.org/drawingml/2006/main" prst="rect">
             <a:avLst/>
@@ -7305,13 +8148,13 @@
           </a:ln>
         </p:spPr>
         <p:txBody>
-          <a:bodyPr xmlns:a="http://schemas.openxmlformats.org/drawingml/2006/main">
+          <a:bodyPr xmlns:a="http://schemas.openxmlformats.org/drawingml/2006/main" anchor="ctr">
             <a:noAutofit/>
           </a:bodyPr>
           <a:lstStyle xmlns:a="http://schemas.openxmlformats.org/drawingml/2006/main"/>
           <a:p xmlns:a="http://schemas.openxmlformats.org/drawingml/2006/main">
-            <a:pPr>
-              <a:defRPr sz="3150" b="1">
+            <a:pPr algn="l">
+              <a:defRPr sz="2700" b="1">
                 <a:solidFill>
                   <a:srgbClr val="161616"/>
                 </a:solidFill>
@@ -7321,7 +8164,7 @@
               </a:defRPr>
             </a:pPr>
             <a:r>
-              <a:rPr sz="3150" b="1">
+              <a:rPr sz="2700" b="1">
                 <a:solidFill>
                   <a:srgbClr val="161616"/>
                 </a:solidFill>
@@ -7339,7 +8182,7 @@
           <p:cNvPr id="2" name="">
             <a:extLst xmlns:a="http://schemas.openxmlformats.org/drawingml/2006/main">
               <a:ext uri="{FF2B5EF4-FFF2-40B4-BE49-F238E27FC236}">
-                <a16:creationId xmlns:a16="http://schemas.microsoft.com/office/drawing/2014/main" id="{35D0DB52-844B-4CD5-8074-13B0B558C570}"/>
+                <a16:creationId xmlns:a16="http://schemas.microsoft.com/office/drawing/2014/main" id="{9006BFE0-A405-491C-B15E-56FFAE2585AA}"/>
               </a:ext>
             </a:extLst>
           </p:cNvPr>
@@ -7396,7 +8239,7 @@
           <p:cNvPr id="3" name="">
             <a:extLst xmlns:a="http://schemas.openxmlformats.org/drawingml/2006/main">
               <a:ext uri="{FF2B5EF4-FFF2-40B4-BE49-F238E27FC236}">
-                <a16:creationId xmlns:a16="http://schemas.microsoft.com/office/drawing/2014/main" id="{5725911D-ED3F-4B15-8562-3EE2716584C7}"/>
+                <a16:creationId xmlns:a16="http://schemas.microsoft.com/office/drawing/2014/main" id="{B4D0C7AD-9743-46EC-80DE-07DD1A8C599E}"/>
               </a:ext>
             </a:extLst>
           </p:cNvPr>
@@ -7453,7 +8296,7 @@
           <p:cNvPr id="4" name="">
             <a:extLst xmlns:a="http://schemas.openxmlformats.org/drawingml/2006/main">
               <a:ext uri="{FF2B5EF4-FFF2-40B4-BE49-F238E27FC236}">
-                <a16:creationId xmlns:a16="http://schemas.microsoft.com/office/drawing/2014/main" id="{4A704F78-B727-4ABF-A175-3AEA26E14F1A}"/>
+                <a16:creationId xmlns:a16="http://schemas.microsoft.com/office/drawing/2014/main" id="{2C046881-2FDB-431F-8468-9FB672BCA766}"/>
               </a:ext>
             </a:extLst>
           </p:cNvPr>
@@ -7510,7 +8353,7 @@
           <p:cNvPr id="5" name="">
             <a:extLst xmlns:a="http://schemas.openxmlformats.org/drawingml/2006/main">
               <a:ext uri="{FF2B5EF4-FFF2-40B4-BE49-F238E27FC236}">
-                <a16:creationId xmlns:a16="http://schemas.microsoft.com/office/drawing/2014/main" id="{00B2B5F6-491B-42CD-9700-7A072D417231}"/>
+                <a16:creationId xmlns:a16="http://schemas.microsoft.com/office/drawing/2014/main" id="{89122CCD-C7EC-465F-86E1-186F8B0BCE96}"/>
               </a:ext>
             </a:extLst>
           </p:cNvPr>
@@ -7557,7 +8400,7 @@
                 <a:ea typeface="Arial"/>
                 <a:cs typeface="Arial"/>
               </a:rPr>
-              <a:t>FR-02 Версии состава.</a:t>
+              <a:t>FR-02 модельный ряд: корпус и уникальный код.</a:t>
             </a:r>
           </a:p>
         </p:txBody>
@@ -7567,7 +8410,7 @@
           <p:cNvPr id="6" name="">
             <a:extLst xmlns:a="http://schemas.openxmlformats.org/drawingml/2006/main">
               <a:ext uri="{FF2B5EF4-FFF2-40B4-BE49-F238E27FC236}">
-                <a16:creationId xmlns:a16="http://schemas.microsoft.com/office/drawing/2014/main" id="{E3645916-2169-40A7-AB97-4D6B23FA6130}"/>
+                <a16:creationId xmlns:a16="http://schemas.microsoft.com/office/drawing/2014/main" id="{5AC59CD3-CCCE-4457-BDD3-C770D32DE876}"/>
               </a:ext>
             </a:extLst>
           </p:cNvPr>
@@ -7624,7 +8467,7 @@
           <p:cNvPr id="7" name="">
             <a:extLst xmlns:a="http://schemas.openxmlformats.org/drawingml/2006/main">
               <a:ext uri="{FF2B5EF4-FFF2-40B4-BE49-F238E27FC236}">
-                <a16:creationId xmlns:a16="http://schemas.microsoft.com/office/drawing/2014/main" id="{1AAC7CD5-2559-46EE-A565-BF4E37D5CC38}"/>
+                <a16:creationId xmlns:a16="http://schemas.microsoft.com/office/drawing/2014/main" id="{96EC8F8F-4F40-4E69-9DF3-E46F48DEA04E}"/>
               </a:ext>
             </a:extLst>
           </p:cNvPr>
@@ -7671,7 +8514,7 @@
                 <a:ea typeface="Arial"/>
                 <a:cs typeface="Arial"/>
               </a:rPr>
-              <a:t>FR-04 Автоматическая совместимость.</a:t>
+              <a:t>FR-04 Проверка правил при изменении модельного ряда.</a:t>
             </a:r>
           </a:p>
         </p:txBody>
@@ -7681,7 +8524,7 @@
           <p:cNvPr id="8" name="">
             <a:extLst xmlns:a="http://schemas.openxmlformats.org/drawingml/2006/main">
               <a:ext uri="{FF2B5EF4-FFF2-40B4-BE49-F238E27FC236}">
-                <a16:creationId xmlns:a16="http://schemas.microsoft.com/office/drawing/2014/main" id="{41CE0E82-FF69-46CC-9A25-C2B2EC27E63C}"/>
+                <a16:creationId xmlns:a16="http://schemas.microsoft.com/office/drawing/2014/main" id="{D5FED784-FDC8-4026-A34F-D88EC52E1E76}"/>
               </a:ext>
             </a:extLst>
           </p:cNvPr>
@@ -7728,7 +8571,7 @@
                 <a:ea typeface="Arial"/>
                 <a:cs typeface="Arial"/>
               </a:rPr>
-              <a:t>FR-05 Протокол конфликтов.</a:t>
+              <a:t>FR-05 Правило и компоненты конфликта.</a:t>
             </a:r>
           </a:p>
         </p:txBody>
@@ -7738,7 +8581,7 @@
           <p:cNvPr id="9" name="">
             <a:extLst xmlns:a="http://schemas.openxmlformats.org/drawingml/2006/main">
               <a:ext uri="{FF2B5EF4-FFF2-40B4-BE49-F238E27FC236}">
-                <a16:creationId xmlns:a16="http://schemas.microsoft.com/office/drawing/2014/main" id="{E84FD8CF-7C95-4164-83BB-50AEBDD1A8CE}"/>
+                <a16:creationId xmlns:a16="http://schemas.microsoft.com/office/drawing/2014/main" id="{CCC1DD2A-9434-45BF-99AB-5D1E8F53905F}"/>
               </a:ext>
             </a:extLst>
           </p:cNvPr>
@@ -7785,7 +8628,7 @@
                 <a:ea typeface="Arial"/>
                 <a:cs typeface="Arial"/>
               </a:rPr>
-              <a:t>FR-06 Сопоставление SKU.</a:t>
+              <a:t>FR-06 Сопоставление компонентов и SKU.</a:t>
             </a:r>
           </a:p>
         </p:txBody>
@@ -7795,7 +8638,7 @@
           <p:cNvPr id="10" name="">
             <a:extLst xmlns:a="http://schemas.openxmlformats.org/drawingml/2006/main">
               <a:ext uri="{FF2B5EF4-FFF2-40B4-BE49-F238E27FC236}">
-                <a16:creationId xmlns:a16="http://schemas.microsoft.com/office/drawing/2014/main" id="{46B4C9D7-2ACD-41F9-B2F4-8D74B54C07D6}"/>
+                <a16:creationId xmlns:a16="http://schemas.microsoft.com/office/drawing/2014/main" id="{D35FA6FB-FDB2-454E-92D8-69A6E6D9BE61}"/>
               </a:ext>
             </a:extLst>
           </p:cNvPr>
@@ -7842,7 +8685,7 @@
                 <a:ea typeface="Arial"/>
                 <a:cs typeface="Arial"/>
               </a:rPr>
-              <a:t>FR-07 Импорт предложений.</a:t>
+              <a:t>FR-07 Импорт цен, наличия и даты.</a:t>
             </a:r>
           </a:p>
         </p:txBody>
@@ -7852,7 +8695,7 @@
           <p:cNvPr id="11" name="">
             <a:extLst xmlns:a="http://schemas.openxmlformats.org/drawingml/2006/main">
               <a:ext uri="{FF2B5EF4-FFF2-40B4-BE49-F238E27FC236}">
-                <a16:creationId xmlns:a16="http://schemas.microsoft.com/office/drawing/2014/main" id="{BF722F24-6724-41C8-8F74-F415AAC62B6E}"/>
+                <a16:creationId xmlns:a16="http://schemas.microsoft.com/office/drawing/2014/main" id="{833B3E60-DBDA-4CDC-BCC3-5D841CE931ED}"/>
               </a:ext>
             </a:extLst>
           </p:cNvPr>
@@ -7899,7 +8742,7 @@
                 <a:ea typeface="Arial"/>
                 <a:cs typeface="Arial"/>
               </a:rPr>
-              <a:t>FR-08 Выбор актуального предложения.</a:t>
+              <a:t>FR-08 Выбор по правилам приоритета.</a:t>
             </a:r>
           </a:p>
         </p:txBody>
@@ -7909,7 +8752,7 @@
           <p:cNvPr id="12" name="">
             <a:extLst xmlns:a="http://schemas.openxmlformats.org/drawingml/2006/main">
               <a:ext uri="{FF2B5EF4-FFF2-40B4-BE49-F238E27FC236}">
-                <a16:creationId xmlns:a16="http://schemas.microsoft.com/office/drawing/2014/main" id="{DA7D6554-5A20-4CD6-A0D0-2D046C63A2D8}"/>
+                <a16:creationId xmlns:a16="http://schemas.microsoft.com/office/drawing/2014/main" id="{9716E9CE-4411-49C4-B2AB-AF7FBB61A743}"/>
               </a:ext>
             </a:extLst>
           </p:cNvPr>
@@ -7956,7 +8799,7 @@
                 <a:ea typeface="Arial"/>
                 <a:cs typeface="Arial"/>
               </a:rPr>
-              <a:t>FR-09 Расчёт цены.</a:t>
+              <a:t>FR-09 Себестоимость и цена карточки.</a:t>
             </a:r>
           </a:p>
         </p:txBody>
@@ -7966,7 +8809,7 @@
           <p:cNvPr id="13" name="">
             <a:extLst xmlns:a="http://schemas.openxmlformats.org/drawingml/2006/main">
               <a:ext uri="{FF2B5EF4-FFF2-40B4-BE49-F238E27FC236}">
-                <a16:creationId xmlns:a16="http://schemas.microsoft.com/office/drawing/2014/main" id="{0F8F84FE-5D6F-4F76-8970-D6D4195A66B4}"/>
+                <a16:creationId xmlns:a16="http://schemas.microsoft.com/office/drawing/2014/main" id="{78EDAD4D-C0FD-4042-8908-FC3BF9EA01DF}"/>
               </a:ext>
             </a:extLst>
           </p:cNvPr>
@@ -8013,7 +8856,7 @@
                 <a:ea typeface="Arial"/>
                 <a:cs typeface="Arial"/>
               </a:rPr>
-              <a:t>FR-10 Расчёт массы.</a:t>
+              <a:t>FR-10 Масса товара с упаковкой.</a:t>
             </a:r>
           </a:p>
         </p:txBody>
@@ -8021,7 +8864,7 @@
     </p:spTree>
     <p:extLst>
       <p:ext uri="{BB962C8B-B14F-4D97-AF65-F5344CB8AC3E}">
-        <p14:creationId xmlns:p14="http://schemas.microsoft.com/office/powerpoint/2010/main" val="1914241186"/>
+        <p14:creationId xmlns:p14="http://schemas.microsoft.com/office/powerpoint/2010/main" val="1651452437"/>
       </p:ext>
     </p:extLst>
   </p:cSld>
@@ -8052,7 +8895,7 @@
           <p:cNvPr id="16" name="">
             <a:extLst xmlns:a="http://schemas.openxmlformats.org/drawingml/2006/main">
               <a:ext uri="{FF2B5EF4-FFF2-40B4-BE49-F238E27FC236}">
-                <a16:creationId xmlns:a16="http://schemas.microsoft.com/office/drawing/2014/main" id="{5B1C40F1-8AB3-488C-941A-E8F777A20855}"/>
+                <a16:creationId xmlns:a16="http://schemas.microsoft.com/office/drawing/2014/main" id="{D3FCAF60-B9FA-4D71-BD97-C829B3E4B064}"/>
               </a:ext>
             </a:extLst>
           </p:cNvPr>
@@ -8063,8 +8906,8 @@
         </p:nvSpPr>
         <p:spPr>
           <a:xfrm xmlns:a="http://schemas.openxmlformats.org/drawingml/2006/main">
-            <a:off x="552450" y="333375"/>
-            <a:ext cx="11049000" cy="857250"/>
+            <a:off x="552450" y="266700"/>
+            <a:ext cx="11049000" cy="742950"/>
           </a:xfrm>
           <a:prstGeom xmlns:a="http://schemas.openxmlformats.org/drawingml/2006/main" prst="rect">
             <a:avLst/>
@@ -8075,13 +8918,13 @@
           </a:ln>
         </p:spPr>
         <p:txBody>
-          <a:bodyPr xmlns:a="http://schemas.openxmlformats.org/drawingml/2006/main">
+          <a:bodyPr xmlns:a="http://schemas.openxmlformats.org/drawingml/2006/main" anchor="ctr">
             <a:noAutofit/>
           </a:bodyPr>
           <a:lstStyle xmlns:a="http://schemas.openxmlformats.org/drawingml/2006/main"/>
           <a:p xmlns:a="http://schemas.openxmlformats.org/drawingml/2006/main">
-            <a:pPr>
-              <a:defRPr sz="3150" b="1">
+            <a:pPr algn="l">
+              <a:defRPr sz="2700" b="1">
                 <a:solidFill>
                   <a:srgbClr val="161616"/>
                 </a:solidFill>
@@ -8091,7 +8934,7 @@
               </a:defRPr>
             </a:pPr>
             <a:r>
-              <a:rPr sz="3150" b="1">
+              <a:rPr sz="2700" b="1">
                 <a:solidFill>
                   <a:srgbClr val="161616"/>
                 </a:solidFill>
@@ -8109,7 +8952,7 @@
           <p:cNvPr id="2" name="">
             <a:extLst xmlns:a="http://schemas.openxmlformats.org/drawingml/2006/main">
               <a:ext uri="{FF2B5EF4-FFF2-40B4-BE49-F238E27FC236}">
-                <a16:creationId xmlns:a16="http://schemas.microsoft.com/office/drawing/2014/main" id="{92608AF8-0E59-452D-B4FB-17CFA5D082AA}"/>
+                <a16:creationId xmlns:a16="http://schemas.microsoft.com/office/drawing/2014/main" id="{C90C60B7-CB18-4078-93C7-05D5B48BC593}"/>
               </a:ext>
             </a:extLst>
           </p:cNvPr>
@@ -8156,7 +8999,7 @@
                 <a:ea typeface="Arial"/>
                 <a:cs typeface="Arial"/>
               </a:rPr>
-              <a:t>Изменения и публикация</a:t>
+              <a:t>Изменения и контент</a:t>
             </a:r>
           </a:p>
         </p:txBody>
@@ -8166,7 +9009,7 @@
           <p:cNvPr id="3" name="">
             <a:extLst xmlns:a="http://schemas.openxmlformats.org/drawingml/2006/main">
               <a:ext uri="{FF2B5EF4-FFF2-40B4-BE49-F238E27FC236}">
-                <a16:creationId xmlns:a16="http://schemas.microsoft.com/office/drawing/2014/main" id="{1DBA11CB-3462-43A6-BC49-107AD319D2FE}"/>
+                <a16:creationId xmlns:a16="http://schemas.microsoft.com/office/drawing/2014/main" id="{090B1535-2729-4954-A027-99A5A24C345C}"/>
               </a:ext>
             </a:extLst>
           </p:cNvPr>
@@ -8213,7 +9056,7 @@
                 <a:ea typeface="Arial"/>
                 <a:cs typeface="Arial"/>
               </a:rPr>
-              <a:t>Результат и история</a:t>
+              <a:t>Публикация и история</a:t>
             </a:r>
           </a:p>
         </p:txBody>
@@ -8223,7 +9066,7 @@
           <p:cNvPr id="4" name="">
             <a:extLst xmlns:a="http://schemas.openxmlformats.org/drawingml/2006/main">
               <a:ext uri="{FF2B5EF4-FFF2-40B4-BE49-F238E27FC236}">
-                <a16:creationId xmlns:a16="http://schemas.microsoft.com/office/drawing/2014/main" id="{1B0A5E6E-F158-4362-9E3E-E1F1F94FA90A}"/>
+                <a16:creationId xmlns:a16="http://schemas.microsoft.com/office/drawing/2014/main" id="{E1FB9880-709D-4018-AB74-89D76348EA2A}"/>
               </a:ext>
             </a:extLst>
           </p:cNvPr>
@@ -8270,7 +9113,7 @@
                 <a:ea typeface="Arial"/>
                 <a:cs typeface="Arial"/>
               </a:rPr>
-              <a:t>FR-11 Предпросмотр массовой замены.</a:t>
+              <a:t>FR-11 Поиск модельных рядов с компонентом или SKU.</a:t>
             </a:r>
           </a:p>
         </p:txBody>
@@ -8280,7 +9123,7 @@
           <p:cNvPr id="5" name="">
             <a:extLst xmlns:a="http://schemas.openxmlformats.org/drawingml/2006/main">
               <a:ext uri="{FF2B5EF4-FFF2-40B4-BE49-F238E27FC236}">
-                <a16:creationId xmlns:a16="http://schemas.microsoft.com/office/drawing/2014/main" id="{B97D631B-0126-46BC-BE22-F36CE5706500}"/>
+                <a16:creationId xmlns:a16="http://schemas.microsoft.com/office/drawing/2014/main" id="{B99636D6-A8AC-486D-ACE9-A396C38A1D1F}"/>
               </a:ext>
             </a:extLst>
           </p:cNvPr>
@@ -8327,7 +9170,7 @@
                 <a:ea typeface="Arial"/>
                 <a:cs typeface="Arial"/>
               </a:rPr>
-              <a:t>FR-12 Новая версия при замене.</a:t>
+              <a:t>FR-12 Замена после предпросмотра.</a:t>
             </a:r>
           </a:p>
         </p:txBody>
@@ -8337,7 +9180,7 @@
           <p:cNvPr id="6" name="">
             <a:extLst xmlns:a="http://schemas.openxmlformats.org/drawingml/2006/main">
               <a:ext uri="{FF2B5EF4-FFF2-40B4-BE49-F238E27FC236}">
-                <a16:creationId xmlns:a16="http://schemas.microsoft.com/office/drawing/2014/main" id="{FE0C969D-AE37-468E-86F8-B20EFDFBE99F}"/>
+                <a16:creationId xmlns:a16="http://schemas.microsoft.com/office/drawing/2014/main" id="{9E6C94B0-FD60-4D9F-86CF-BB70DBF64389}"/>
               </a:ext>
             </a:extLst>
           </p:cNvPr>
@@ -8384,7 +9227,7 @@
                 <a:ea typeface="Arial"/>
                 <a:cs typeface="Arial"/>
               </a:rPr>
-              <a:t>FR-13 Повторная проверка.</a:t>
+              <a:t>FR-13 Повторная проверка всех изменений.</a:t>
             </a:r>
           </a:p>
         </p:txBody>
@@ -8394,7 +9237,7 @@
           <p:cNvPr id="7" name="">
             <a:extLst xmlns:a="http://schemas.openxmlformats.org/drawingml/2006/main">
               <a:ext uri="{FF2B5EF4-FFF2-40B4-BE49-F238E27FC236}">
-                <a16:creationId xmlns:a16="http://schemas.microsoft.com/office/drawing/2014/main" id="{23236F71-E7CE-45FE-AF66-0924D63A26C1}"/>
+                <a16:creationId xmlns:a16="http://schemas.microsoft.com/office/drawing/2014/main" id="{2DBB4FBE-5D14-41D5-AB32-CD03B03EAA32}"/>
               </a:ext>
             </a:extLst>
           </p:cNvPr>
@@ -8441,7 +9284,7 @@
                 <a:ea typeface="Arial"/>
                 <a:cs typeface="Arial"/>
               </a:rPr>
-              <a:t>FR-14 Контент и изображения.</a:t>
+              <a:t>FR-14 Изображения по шаблонам.</a:t>
             </a:r>
           </a:p>
         </p:txBody>
@@ -8451,7 +9294,7 @@
           <p:cNvPr id="8" name="">
             <a:extLst xmlns:a="http://schemas.openxmlformats.org/drawingml/2006/main">
               <a:ext uri="{FF2B5EF4-FFF2-40B4-BE49-F238E27FC236}">
-                <a16:creationId xmlns:a16="http://schemas.microsoft.com/office/drawing/2014/main" id="{A05DEACB-DA7B-4A8E-BD84-CC4B642EEB4E}"/>
+                <a16:creationId xmlns:a16="http://schemas.microsoft.com/office/drawing/2014/main" id="{A7CAFB75-3551-4935-B3D2-A6DCE746FF70}"/>
               </a:ext>
             </a:extLst>
           </p:cNvPr>
@@ -8498,7 +9341,7 @@
                 <a:ea typeface="Arial"/>
                 <a:cs typeface="Arial"/>
               </a:rPr>
-              <a:t>FR-15 Карточка из одной версии.</a:t>
+              <a:t>FR-15 Название, описание и характеристики.</a:t>
             </a:r>
           </a:p>
         </p:txBody>
@@ -8508,7 +9351,7 @@
           <p:cNvPr id="9" name="">
             <a:extLst xmlns:a="http://schemas.openxmlformats.org/drawingml/2006/main">
               <a:ext uri="{FF2B5EF4-FFF2-40B4-BE49-F238E27FC236}">
-                <a16:creationId xmlns:a16="http://schemas.microsoft.com/office/drawing/2014/main" id="{4AFD9DD9-1434-4E48-9E58-DA4C0B984D31}"/>
+                <a16:creationId xmlns:a16="http://schemas.microsoft.com/office/drawing/2014/main" id="{35A7083E-9B00-4C66-9F81-942B73A9CBF3}"/>
               </a:ext>
             </a:extLst>
           </p:cNvPr>
@@ -8555,7 +9398,7 @@
                 <a:ea typeface="Arial"/>
                 <a:cs typeface="Arial"/>
               </a:rPr>
-              <a:t>FR-16 Контроль готовности.</a:t>
+              <a:t>FR-16 Обязательные атрибуты Ozon.</a:t>
             </a:r>
           </a:p>
         </p:txBody>
@@ -8565,7 +9408,7 @@
           <p:cNvPr id="10" name="">
             <a:extLst xmlns:a="http://schemas.openxmlformats.org/drawingml/2006/main">
               <a:ext uri="{FF2B5EF4-FFF2-40B4-BE49-F238E27FC236}">
-                <a16:creationId xmlns:a16="http://schemas.microsoft.com/office/drawing/2014/main" id="{7C0B7C84-06EE-44E0-AD99-654F907A4D04}"/>
+                <a16:creationId xmlns:a16="http://schemas.microsoft.com/office/drawing/2014/main" id="{520AD5AB-E2C0-4C0E-9104-8A4CF1806336}"/>
               </a:ext>
             </a:extLst>
           </p:cNvPr>
@@ -8612,7 +9455,7 @@
                 <a:ea typeface="Arial"/>
                 <a:cs typeface="Arial"/>
               </a:rPr>
-              <a:t>FR-17 Очередь публикации.</a:t>
+              <a:t>FR-17 Создание и обновление через API.</a:t>
             </a:r>
           </a:p>
         </p:txBody>
@@ -8622,7 +9465,7 @@
           <p:cNvPr id="11" name="">
             <a:extLst xmlns:a="http://schemas.openxmlformats.org/drawingml/2006/main">
               <a:ext uri="{FF2B5EF4-FFF2-40B4-BE49-F238E27FC236}">
-                <a16:creationId xmlns:a16="http://schemas.microsoft.com/office/drawing/2014/main" id="{9129A45A-BE4E-4792-A6B2-43DA4799E038}"/>
+                <a16:creationId xmlns:a16="http://schemas.microsoft.com/office/drawing/2014/main" id="{0BCC0040-A411-4D58-86EC-B2BB268FCF54}"/>
               </a:ext>
             </a:extLst>
           </p:cNvPr>
@@ -8669,7 +9512,7 @@
                 <a:ea typeface="Arial"/>
                 <a:cs typeface="Arial"/>
               </a:rPr>
-              <a:t>FR-18 Статус и внешний ID.</a:t>
+              <a:t>FR-18 ID операции, ответ и итоговый статус.</a:t>
             </a:r>
           </a:p>
         </p:txBody>
@@ -8679,7 +9522,7 @@
           <p:cNvPr id="12" name="">
             <a:extLst xmlns:a="http://schemas.openxmlformats.org/drawingml/2006/main">
               <a:ext uri="{FF2B5EF4-FFF2-40B4-BE49-F238E27FC236}">
-                <a16:creationId xmlns:a16="http://schemas.microsoft.com/office/drawing/2014/main" id="{C20E801A-4341-4B8A-850C-D0571CD586C7}"/>
+                <a16:creationId xmlns:a16="http://schemas.microsoft.com/office/drawing/2014/main" id="{CB824B69-64A1-4D82-A0B5-5A7DDEA8AD86}"/>
               </a:ext>
             </a:extLst>
           </p:cNvPr>
@@ -8726,7 +9569,7 @@
                 <a:ea typeface="Arial"/>
                 <a:cs typeface="Arial"/>
               </a:rPr>
-              <a:t>FR-19 Ограниченные повторы.</a:t>
+              <a:t>FR-19 Очередь повторной отправки.</a:t>
             </a:r>
           </a:p>
         </p:txBody>
@@ -8736,7 +9579,7 @@
           <p:cNvPr id="13" name="">
             <a:extLst xmlns:a="http://schemas.openxmlformats.org/drawingml/2006/main">
               <a:ext uri="{FF2B5EF4-FFF2-40B4-BE49-F238E27FC236}">
-                <a16:creationId xmlns:a16="http://schemas.microsoft.com/office/drawing/2014/main" id="{E2C67A30-620E-4E0C-BD52-8E87CDD4E893}"/>
+                <a16:creationId xmlns:a16="http://schemas.microsoft.com/office/drawing/2014/main" id="{51DE6C7E-4650-4190-BD78-51AC28CDE7A6}"/>
               </a:ext>
             </a:extLst>
           </p:cNvPr>
@@ -8783,7 +9626,7 @@
                 <a:ea typeface="Arial"/>
                 <a:cs typeface="Arial"/>
               </a:rPr>
-              <a:t>FR-20 Аудит изменений.</a:t>
+              <a:t>FR-20 История версий и действий.</a:t>
             </a:r>
           </a:p>
         </p:txBody>
@@ -8793,7 +9636,7 @@
           <p:cNvPr id="14" name="">
             <a:extLst xmlns:a="http://schemas.openxmlformats.org/drawingml/2006/main">
               <a:ext uri="{FF2B5EF4-FFF2-40B4-BE49-F238E27FC236}">
-                <a16:creationId xmlns:a16="http://schemas.microsoft.com/office/drawing/2014/main" id="{35C9A2A0-0A1A-4AA3-80F9-324F51FD44EC}"/>
+                <a16:creationId xmlns:a16="http://schemas.microsoft.com/office/drawing/2014/main" id="{FBF6238A-2E0F-44D6-8DE7-B3678922376F}"/>
               </a:ext>
             </a:extLst>
           </p:cNvPr>
@@ -8840,7 +9683,7 @@
                 <a:ea typeface="Arial"/>
                 <a:cs typeface="Arial"/>
               </a:rPr>
-              <a:t>FR-21 Уведомления.</a:t>
+              <a:t>FR-21 Уведомления об ошибках.</a:t>
             </a:r>
           </a:p>
         </p:txBody>
@@ -8850,7 +9693,7 @@
           <p:cNvPr id="15" name="">
             <a:extLst xmlns:a="http://schemas.openxmlformats.org/drawingml/2006/main">
               <a:ext uri="{FF2B5EF4-FFF2-40B4-BE49-F238E27FC236}">
-                <a16:creationId xmlns:a16="http://schemas.microsoft.com/office/drawing/2014/main" id="{396C6A85-8F0E-415B-B282-E307323590C9}"/>
+                <a16:creationId xmlns:a16="http://schemas.microsoft.com/office/drawing/2014/main" id="{E5FAA611-03F2-47FA-8E0B-EA3A10066945}"/>
               </a:ext>
             </a:extLst>
           </p:cNvPr>
@@ -8905,7 +9748,7 @@
     </p:spTree>
     <p:extLst>
       <p:ext uri="{BB962C8B-B14F-4D97-AF65-F5344CB8AC3E}">
-        <p14:creationId xmlns:p14="http://schemas.microsoft.com/office/powerpoint/2010/main" val="711244235"/>
+        <p14:creationId xmlns:p14="http://schemas.microsoft.com/office/powerpoint/2010/main" val="1883853679"/>
       </p:ext>
     </p:extLst>
   </p:cSld>

</xml_diff>